<commit_message>
fix(pptx): Wave 1~3 MECE audit remediation (P0~P2)
- D01/D02: Preserve asking price precision with .toFixed(2)

- D03: Fix rent roll annual rent precision

- D04: Adjust Cap Rate/NOI cross-validation tolerance

- D05: Add shrinkText to A01 cover

- D07: Add posture check to financial slides

- D11: Fix golden-test-factory map assertion

- D12: Unify pyeong-to-sqm constant

- D13: Preserve rent roll area decimal

- D15: Fix rent roll creation check

- D16: Add Premium Template fallback if stripJsonLeaks empties markdown
</commit_message>
<xml_diff>
--- a/docs/test/stress/e2e-outputs/development_basic_pr04.pptx
+++ b/docs/test/stress/e2e-outputs/development_basic_pr04.pptx
@@ -1916,7 +1916,7 @@
         </p:nvSpPr>
         <p:spPr>
           <a:xfrm>
-            <a:off x="502920" y="475488"/>
+            <a:off x="566928" y="475488"/>
             <a:ext cx="2743200" cy="365760"/>
           </a:xfrm>
           <a:prstGeom prst="rect">
@@ -1969,7 +1969,7 @@
         </p:nvSpPr>
         <p:spPr>
           <a:xfrm>
-            <a:off x="502920" y="2029968"/>
+            <a:off x="566928" y="2029968"/>
             <a:ext cx="7315200" cy="274320"/>
           </a:xfrm>
           <a:prstGeom prst="rect">
@@ -2008,8 +2008,8 @@
         </p:nvSpPr>
         <p:spPr>
           <a:xfrm>
-            <a:off x="502920" y="2304288"/>
-            <a:ext cx="7315200" cy="731520"/>
+            <a:off x="566928" y="2304288"/>
+            <a:ext cx="7315200" cy="1051560"/>
           </a:xfrm>
           <a:prstGeom prst="rect">
             <a:avLst/>
@@ -2025,7 +2025,7 @@
               <a:buNone/>
             </a:pPr>
             <a:r>
-              <a:rPr lang="en-US" sz="3000" b="1" dirty="0">
+              <a:rPr lang="en-US" sz="2600" b="1" dirty="0">
                 <a:solidFill>
                   <a:srgbClr val="FFFFFF"/>
                 </a:solidFill>
@@ -2035,7 +2035,7 @@
               </a:rPr>
               <a:t>development 포스처 테스트 문서</a:t>
             </a:r>
-            <a:endParaRPr lang="en-US" sz="3000" dirty="0"/>
+            <a:endParaRPr lang="en-US" sz="2600" dirty="0"/>
           </a:p>
         </p:txBody>
       </p:sp>
@@ -2047,7 +2047,7 @@
         </p:nvSpPr>
         <p:spPr>
           <a:xfrm>
-            <a:off x="502920" y="3090672"/>
+            <a:off x="566928" y="3410712"/>
             <a:ext cx="7315200" cy="329184"/>
           </a:xfrm>
           <a:prstGeom prst="rect">
@@ -2086,7 +2086,7 @@
         </p:nvSpPr>
         <p:spPr>
           <a:xfrm>
-            <a:off x="502920" y="3639312"/>
+            <a:off x="566928" y="3959352"/>
             <a:ext cx="1005840" cy="292608"/>
           </a:xfrm>
           <a:prstGeom prst="roundRect">
@@ -2108,7 +2108,7 @@
         </p:nvSpPr>
         <p:spPr>
           <a:xfrm>
-            <a:off x="502920" y="3639312"/>
+            <a:off x="566928" y="3959352"/>
             <a:ext cx="1005840" cy="292608"/>
           </a:xfrm>
           <a:prstGeom prst="rect">
@@ -2147,7 +2147,7 @@
         </p:nvSpPr>
         <p:spPr>
           <a:xfrm>
-            <a:off x="1600200" y="3639312"/>
+            <a:off x="1664208" y="3959352"/>
             <a:ext cx="1005840" cy="292608"/>
           </a:xfrm>
           <a:prstGeom prst="roundRect">
@@ -2169,7 +2169,7 @@
         </p:nvSpPr>
         <p:spPr>
           <a:xfrm>
-            <a:off x="1600200" y="3639312"/>
+            <a:off x="1664208" y="3959352"/>
             <a:ext cx="1005840" cy="292608"/>
           </a:xfrm>
           <a:prstGeom prst="rect">
@@ -2208,7 +2208,7 @@
         </p:nvSpPr>
         <p:spPr>
           <a:xfrm>
-            <a:off x="502920" y="4078224"/>
+            <a:off x="566928" y="4398264"/>
             <a:ext cx="6858000" cy="1051560"/>
           </a:xfrm>
           <a:prstGeom prst="roundRect">
@@ -2235,7 +2235,7 @@
         </p:nvSpPr>
         <p:spPr>
           <a:xfrm>
-            <a:off x="758952" y="4187952"/>
+            <a:off x="822960" y="4507992"/>
             <a:ext cx="6345936" cy="832104"/>
           </a:xfrm>
           <a:prstGeom prst="rect">
@@ -2274,7 +2274,7 @@
         </p:nvSpPr>
         <p:spPr>
           <a:xfrm>
-            <a:off x="502920" y="1700784"/>
+            <a:off x="566928" y="1700784"/>
             <a:ext cx="7315200" cy="256032"/>
           </a:xfrm>
           <a:prstGeom prst="rect">
@@ -2313,8 +2313,8 @@
         </p:nvSpPr>
         <p:spPr>
           <a:xfrm>
-            <a:off x="502920" y="6035040"/>
-            <a:ext cx="11057839" cy="274320"/>
+            <a:off x="566928" y="5943600"/>
+            <a:ext cx="11057839" cy="201168"/>
           </a:xfrm>
           <a:prstGeom prst="rect">
             <a:avLst/>
@@ -2352,7 +2352,7 @@
         </p:nvSpPr>
         <p:spPr>
           <a:xfrm>
-            <a:off x="502920" y="6382512"/>
+            <a:off x="566928" y="6382512"/>
             <a:ext cx="7315200" cy="219456"/>
           </a:xfrm>
           <a:prstGeom prst="rect">
@@ -2391,7 +2391,7 @@
         </p:nvSpPr>
         <p:spPr>
           <a:xfrm>
-            <a:off x="10774375" y="6382512"/>
+            <a:off x="10710367" y="6382512"/>
             <a:ext cx="914400" cy="219456"/>
           </a:xfrm>
           <a:prstGeom prst="rect">
@@ -2462,7 +2462,7 @@
         </p:nvSpPr>
         <p:spPr>
           <a:xfrm>
-            <a:off x="502920" y="457200"/>
+            <a:off x="566928" y="457200"/>
             <a:ext cx="384048" cy="384048"/>
           </a:xfrm>
           <a:prstGeom prst="ellipse">
@@ -2482,7 +2482,7 @@
         </p:nvSpPr>
         <p:spPr>
           <a:xfrm>
-            <a:off x="502920" y="457200"/>
+            <a:off x="566928" y="457200"/>
             <a:ext cx="384048" cy="384048"/>
           </a:xfrm>
           <a:prstGeom prst="rect">
@@ -2521,7 +2521,7 @@
         </p:nvSpPr>
         <p:spPr>
           <a:xfrm>
-            <a:off x="1069848" y="457200"/>
+            <a:off x="1133856" y="457200"/>
             <a:ext cx="10490911" cy="182880"/>
           </a:xfrm>
           <a:prstGeom prst="rect">
@@ -2560,7 +2560,7 @@
         </p:nvSpPr>
         <p:spPr>
           <a:xfrm>
-            <a:off x="1069848" y="640080"/>
+            <a:off x="1133856" y="640080"/>
             <a:ext cx="10490911" cy="365760"/>
           </a:xfrm>
           <a:prstGeom prst="rect">
@@ -2570,7 +2570,9 @@
           <a:ln/>
         </p:spPr>
         <p:txBody>
-          <a:bodyPr wrap="square" lIns="0" tIns="0" rIns="0" bIns="0" rtlCol="0" anchor="ctr"/>
+          <a:bodyPr wrap="square" lIns="0" tIns="0" rIns="0" bIns="0" rtlCol="0" anchor="ctr">
+            <a:normAutofit/>
+          </a:bodyPr>
           <a:lstStyle/>
           <a:p>
             <a:pPr indent="0" marL="0">
@@ -2599,7 +2601,7 @@
         </p:nvSpPr>
         <p:spPr>
           <a:xfrm>
-            <a:off x="502920" y="1572768"/>
+            <a:off x="566928" y="1572768"/>
             <a:ext cx="11057839" cy="3200400"/>
           </a:xfrm>
           <a:prstGeom prst="roundRect">
@@ -2626,7 +2628,7 @@
         </p:nvSpPr>
         <p:spPr>
           <a:xfrm>
-            <a:off x="722376" y="1792224"/>
+            <a:off x="786384" y="1792224"/>
             <a:ext cx="438912" cy="438912"/>
           </a:xfrm>
           <a:prstGeom prst="ellipse">
@@ -2646,7 +2648,7 @@
         </p:nvSpPr>
         <p:spPr>
           <a:xfrm>
-            <a:off x="722376" y="1792224"/>
+            <a:off x="786384" y="1792224"/>
             <a:ext cx="438912" cy="438912"/>
           </a:xfrm>
           <a:prstGeom prst="rect">
@@ -2685,7 +2687,7 @@
         </p:nvSpPr>
         <p:spPr>
           <a:xfrm>
-            <a:off x="722376" y="2304288"/>
+            <a:off x="786384" y="2304288"/>
             <a:ext cx="10618927" cy="365760"/>
           </a:xfrm>
           <a:prstGeom prst="rect">
@@ -2724,7 +2726,7 @@
         </p:nvSpPr>
         <p:spPr>
           <a:xfrm>
-            <a:off x="722376" y="2761488"/>
+            <a:off x="786384" y="2761488"/>
             <a:ext cx="10618927" cy="1828800"/>
           </a:xfrm>
           <a:prstGeom prst="rect">
@@ -2780,7 +2782,7 @@
         </p:nvSpPr>
         <p:spPr>
           <a:xfrm>
-            <a:off x="502920" y="6382512"/>
+            <a:off x="566928" y="6382512"/>
             <a:ext cx="7315200" cy="219456"/>
           </a:xfrm>
           <a:prstGeom prst="rect">
@@ -2819,7 +2821,7 @@
         </p:nvSpPr>
         <p:spPr>
           <a:xfrm>
-            <a:off x="10774375" y="6382512"/>
+            <a:off x="10710367" y="6382512"/>
             <a:ext cx="914400" cy="219456"/>
           </a:xfrm>
           <a:prstGeom prst="rect">
@@ -2890,7 +2892,7 @@
         </p:nvSpPr>
         <p:spPr>
           <a:xfrm>
-            <a:off x="502920" y="457200"/>
+            <a:off x="566928" y="457200"/>
             <a:ext cx="384048" cy="384048"/>
           </a:xfrm>
           <a:prstGeom prst="ellipse">
@@ -2910,7 +2912,7 @@
         </p:nvSpPr>
         <p:spPr>
           <a:xfrm>
-            <a:off x="502920" y="457200"/>
+            <a:off x="566928" y="457200"/>
             <a:ext cx="384048" cy="384048"/>
           </a:xfrm>
           <a:prstGeom prst="rect">
@@ -2949,7 +2951,7 @@
         </p:nvSpPr>
         <p:spPr>
           <a:xfrm>
-            <a:off x="1069848" y="457200"/>
+            <a:off x="1133856" y="457200"/>
             <a:ext cx="10490911" cy="182880"/>
           </a:xfrm>
           <a:prstGeom prst="rect">
@@ -2988,7 +2990,7 @@
         </p:nvSpPr>
         <p:spPr>
           <a:xfrm>
-            <a:off x="1069848" y="658368"/>
+            <a:off x="1133856" y="658368"/>
             <a:ext cx="10490911" cy="420624"/>
           </a:xfrm>
           <a:prstGeom prst="rect">
@@ -2998,7 +3000,9 @@
           <a:ln/>
         </p:spPr>
         <p:txBody>
-          <a:bodyPr wrap="square" lIns="0" tIns="0" rIns="0" bIns="0" rtlCol="0" anchor="ctr"/>
+          <a:bodyPr wrap="square" lIns="0" tIns="0" rIns="0" bIns="0" rtlCol="0" anchor="ctr">
+            <a:normAutofit/>
+          </a:bodyPr>
           <a:lstStyle/>
           <a:p>
             <a:pPr indent="0" marL="0">
@@ -3027,7 +3031,7 @@
         </p:nvSpPr>
         <p:spPr>
           <a:xfrm>
-            <a:off x="502920" y="1463040"/>
+            <a:off x="566928" y="1463040"/>
             <a:ext cx="3588410" cy="658368"/>
           </a:xfrm>
           <a:prstGeom prst="roundRect">
@@ -3049,7 +3053,7 @@
         </p:nvSpPr>
         <p:spPr>
           <a:xfrm>
-            <a:off x="612648" y="1572768"/>
+            <a:off x="676656" y="1572768"/>
             <a:ext cx="438912" cy="438912"/>
           </a:xfrm>
           <a:prstGeom prst="ellipse">
@@ -3069,7 +3073,7 @@
         </p:nvSpPr>
         <p:spPr>
           <a:xfrm>
-            <a:off x="612648" y="1572768"/>
+            <a:off x="676656" y="1572768"/>
             <a:ext cx="438912" cy="438912"/>
           </a:xfrm>
           <a:prstGeom prst="rect">
@@ -3108,7 +3112,7 @@
         </p:nvSpPr>
         <p:spPr>
           <a:xfrm>
-            <a:off x="1161288" y="1554480"/>
+            <a:off x="1225296" y="1554480"/>
             <a:ext cx="2820314" cy="237744"/>
           </a:xfrm>
           <a:prstGeom prst="rect">
@@ -3147,7 +3151,7 @@
         </p:nvSpPr>
         <p:spPr>
           <a:xfrm>
-            <a:off x="1161288" y="1792224"/>
+            <a:off x="1225296" y="1792224"/>
             <a:ext cx="2820314" cy="256032"/>
           </a:xfrm>
           <a:prstGeom prst="rect">
@@ -3186,7 +3190,7 @@
         </p:nvSpPr>
         <p:spPr>
           <a:xfrm>
-            <a:off x="4091330" y="1600200"/>
+            <a:off x="4155338" y="1600200"/>
             <a:ext cx="146304" cy="384048"/>
           </a:xfrm>
           <a:prstGeom prst="rect">
@@ -3225,7 +3229,7 @@
         </p:nvSpPr>
         <p:spPr>
           <a:xfrm>
-            <a:off x="4237634" y="1463040"/>
+            <a:off x="4301642" y="1463040"/>
             <a:ext cx="3588410" cy="658368"/>
           </a:xfrm>
           <a:prstGeom prst="roundRect">
@@ -3247,7 +3251,7 @@
         </p:nvSpPr>
         <p:spPr>
           <a:xfrm>
-            <a:off x="4347362" y="1572768"/>
+            <a:off x="4411370" y="1572768"/>
             <a:ext cx="438912" cy="438912"/>
           </a:xfrm>
           <a:prstGeom prst="ellipse">
@@ -3267,7 +3271,7 @@
         </p:nvSpPr>
         <p:spPr>
           <a:xfrm>
-            <a:off x="4347362" y="1572768"/>
+            <a:off x="4411370" y="1572768"/>
             <a:ext cx="438912" cy="438912"/>
           </a:xfrm>
           <a:prstGeom prst="rect">
@@ -3306,7 +3310,7 @@
         </p:nvSpPr>
         <p:spPr>
           <a:xfrm>
-            <a:off x="4896002" y="1554480"/>
+            <a:off x="4960010" y="1554480"/>
             <a:ext cx="2820314" cy="237744"/>
           </a:xfrm>
           <a:prstGeom prst="rect">
@@ -3345,7 +3349,7 @@
         </p:nvSpPr>
         <p:spPr>
           <a:xfrm>
-            <a:off x="4896002" y="1792224"/>
+            <a:off x="4960010" y="1792224"/>
             <a:ext cx="2820314" cy="256032"/>
           </a:xfrm>
           <a:prstGeom prst="rect">
@@ -3384,7 +3388,7 @@
         </p:nvSpPr>
         <p:spPr>
           <a:xfrm>
-            <a:off x="7826045" y="1600200"/>
+            <a:off x="7890053" y="1600200"/>
             <a:ext cx="146304" cy="384048"/>
           </a:xfrm>
           <a:prstGeom prst="rect">
@@ -3423,7 +3427,7 @@
         </p:nvSpPr>
         <p:spPr>
           <a:xfrm>
-            <a:off x="7972349" y="1463040"/>
+            <a:off x="8036357" y="1463040"/>
             <a:ext cx="3588410" cy="658368"/>
           </a:xfrm>
           <a:prstGeom prst="roundRect">
@@ -3445,7 +3449,7 @@
         </p:nvSpPr>
         <p:spPr>
           <a:xfrm>
-            <a:off x="8082077" y="1572768"/>
+            <a:off x="8146085" y="1572768"/>
             <a:ext cx="438912" cy="438912"/>
           </a:xfrm>
           <a:prstGeom prst="ellipse">
@@ -3465,7 +3469,7 @@
         </p:nvSpPr>
         <p:spPr>
           <a:xfrm>
-            <a:off x="8082077" y="1572768"/>
+            <a:off x="8146085" y="1572768"/>
             <a:ext cx="438912" cy="438912"/>
           </a:xfrm>
           <a:prstGeom prst="rect">
@@ -3504,7 +3508,7 @@
         </p:nvSpPr>
         <p:spPr>
           <a:xfrm>
-            <a:off x="8630717" y="1554480"/>
+            <a:off x="8694725" y="1554480"/>
             <a:ext cx="2820314" cy="237744"/>
           </a:xfrm>
           <a:prstGeom prst="rect">
@@ -3543,7 +3547,7 @@
         </p:nvSpPr>
         <p:spPr>
           <a:xfrm>
-            <a:off x="8630717" y="1792224"/>
+            <a:off x="8694725" y="1792224"/>
             <a:ext cx="2820314" cy="256032"/>
           </a:xfrm>
           <a:prstGeom prst="rect">
@@ -3582,7 +3586,7 @@
         </p:nvSpPr>
         <p:spPr>
           <a:xfrm>
-            <a:off x="502920" y="2395728"/>
+            <a:off x="566928" y="2395728"/>
             <a:ext cx="5486400" cy="237744"/>
           </a:xfrm>
           <a:prstGeom prst="rect">
@@ -3621,7 +3625,7 @@
         </p:nvSpPr>
         <p:spPr>
           <a:xfrm>
-            <a:off x="502920" y="2724912"/>
+            <a:off x="566928" y="2724912"/>
             <a:ext cx="1280160" cy="292608"/>
           </a:xfrm>
           <a:prstGeom prst="roundRect">
@@ -3643,7 +3647,7 @@
         </p:nvSpPr>
         <p:spPr>
           <a:xfrm>
-            <a:off x="502920" y="2724912"/>
+            <a:off x="566928" y="2724912"/>
             <a:ext cx="1280160" cy="292608"/>
           </a:xfrm>
           <a:prstGeom prst="rect">
@@ -3682,7 +3686,7 @@
         </p:nvSpPr>
         <p:spPr>
           <a:xfrm>
-            <a:off x="1929384" y="2706624"/>
+            <a:off x="1993392" y="2706624"/>
             <a:ext cx="3840480" cy="329184"/>
           </a:xfrm>
           <a:prstGeom prst="rect">
@@ -3721,7 +3725,7 @@
         </p:nvSpPr>
         <p:spPr>
           <a:xfrm>
-            <a:off x="502920" y="3127248"/>
+            <a:off x="566928" y="3127248"/>
             <a:ext cx="1280160" cy="292608"/>
           </a:xfrm>
           <a:prstGeom prst="roundRect">
@@ -3743,7 +3747,7 @@
         </p:nvSpPr>
         <p:spPr>
           <a:xfrm>
-            <a:off x="502920" y="3127248"/>
+            <a:off x="566928" y="3127248"/>
             <a:ext cx="1280160" cy="292608"/>
           </a:xfrm>
           <a:prstGeom prst="rect">
@@ -3782,7 +3786,7 @@
         </p:nvSpPr>
         <p:spPr>
           <a:xfrm>
-            <a:off x="1929384" y="3108960"/>
+            <a:off x="1993392" y="3108960"/>
             <a:ext cx="3840480" cy="329184"/>
           </a:xfrm>
           <a:prstGeom prst="rect">
@@ -3821,7 +3825,7 @@
         </p:nvSpPr>
         <p:spPr>
           <a:xfrm>
-            <a:off x="502920" y="3529584"/>
+            <a:off x="566928" y="3529584"/>
             <a:ext cx="1280160" cy="292608"/>
           </a:xfrm>
           <a:prstGeom prst="roundRect">
@@ -3843,7 +3847,7 @@
         </p:nvSpPr>
         <p:spPr>
           <a:xfrm>
-            <a:off x="502920" y="3529584"/>
+            <a:off x="566928" y="3529584"/>
             <a:ext cx="1280160" cy="292608"/>
           </a:xfrm>
           <a:prstGeom prst="rect">
@@ -3882,7 +3886,7 @@
         </p:nvSpPr>
         <p:spPr>
           <a:xfrm>
-            <a:off x="1929384" y="3511296"/>
+            <a:off x="1993392" y="3511296"/>
             <a:ext cx="3840480" cy="329184"/>
           </a:xfrm>
           <a:prstGeom prst="rect">
@@ -3921,7 +3925,7 @@
         </p:nvSpPr>
         <p:spPr>
           <a:xfrm>
-            <a:off x="502920" y="3931920"/>
+            <a:off x="566928" y="3931920"/>
             <a:ext cx="1280160" cy="292608"/>
           </a:xfrm>
           <a:prstGeom prst="roundRect">
@@ -3943,7 +3947,7 @@
         </p:nvSpPr>
         <p:spPr>
           <a:xfrm>
-            <a:off x="502920" y="3931920"/>
+            <a:off x="566928" y="3931920"/>
             <a:ext cx="1280160" cy="292608"/>
           </a:xfrm>
           <a:prstGeom prst="rect">
@@ -3982,7 +3986,7 @@
         </p:nvSpPr>
         <p:spPr>
           <a:xfrm>
-            <a:off x="1929384" y="3913632"/>
+            <a:off x="1993392" y="3913632"/>
             <a:ext cx="3840480" cy="329184"/>
           </a:xfrm>
           <a:prstGeom prst="rect">
@@ -4021,7 +4025,7 @@
         </p:nvSpPr>
         <p:spPr>
           <a:xfrm>
-            <a:off x="502920" y="4334256"/>
+            <a:off x="566928" y="4334256"/>
             <a:ext cx="1280160" cy="292608"/>
           </a:xfrm>
           <a:prstGeom prst="roundRect">
@@ -4043,7 +4047,7 @@
         </p:nvSpPr>
         <p:spPr>
           <a:xfrm>
-            <a:off x="502920" y="4334256"/>
+            <a:off x="566928" y="4334256"/>
             <a:ext cx="1280160" cy="292608"/>
           </a:xfrm>
           <a:prstGeom prst="rect">
@@ -4082,7 +4086,7 @@
         </p:nvSpPr>
         <p:spPr>
           <a:xfrm>
-            <a:off x="1929384" y="4315968"/>
+            <a:off x="1993392" y="4315968"/>
             <a:ext cx="3840480" cy="329184"/>
           </a:xfrm>
           <a:prstGeom prst="rect">
@@ -4224,7 +4228,7 @@
         </p:nvSpPr>
         <p:spPr>
           <a:xfrm>
-            <a:off x="502920" y="5760720"/>
+            <a:off x="566928" y="5760720"/>
             <a:ext cx="11057839" cy="457200"/>
           </a:xfrm>
           <a:prstGeom prst="rect">
@@ -4244,7 +4248,7 @@
         </p:nvSpPr>
         <p:spPr>
           <a:xfrm>
-            <a:off x="685800" y="5806440"/>
+            <a:off x="749808" y="5806440"/>
             <a:ext cx="10692079" cy="365760"/>
           </a:xfrm>
           <a:prstGeom prst="rect">
@@ -4283,7 +4287,7 @@
         </p:nvSpPr>
         <p:spPr>
           <a:xfrm>
-            <a:off x="502920" y="6382512"/>
+            <a:off x="566928" y="6382512"/>
             <a:ext cx="7315200" cy="219456"/>
           </a:xfrm>
           <a:prstGeom prst="rect">
@@ -4322,7 +4326,7 @@
         </p:nvSpPr>
         <p:spPr>
           <a:xfrm>
-            <a:off x="10774375" y="6382512"/>
+            <a:off x="10710367" y="6382512"/>
             <a:ext cx="914400" cy="219456"/>
           </a:xfrm>
           <a:prstGeom prst="rect">
@@ -4393,7 +4397,7 @@
         </p:nvSpPr>
         <p:spPr>
           <a:xfrm>
-            <a:off x="502920" y="457200"/>
+            <a:off x="566928" y="457200"/>
             <a:ext cx="384048" cy="384048"/>
           </a:xfrm>
           <a:prstGeom prst="ellipse">
@@ -4413,7 +4417,7 @@
         </p:nvSpPr>
         <p:spPr>
           <a:xfrm>
-            <a:off x="502920" y="457200"/>
+            <a:off x="566928" y="457200"/>
             <a:ext cx="384048" cy="384048"/>
           </a:xfrm>
           <a:prstGeom prst="rect">
@@ -4452,7 +4456,7 @@
         </p:nvSpPr>
         <p:spPr>
           <a:xfrm>
-            <a:off x="1069848" y="457200"/>
+            <a:off x="1133856" y="457200"/>
             <a:ext cx="10490911" cy="182880"/>
           </a:xfrm>
           <a:prstGeom prst="rect">
@@ -4491,7 +4495,7 @@
         </p:nvSpPr>
         <p:spPr>
           <a:xfrm>
-            <a:off x="1069848" y="640080"/>
+            <a:off x="1133856" y="640080"/>
             <a:ext cx="10490911" cy="365760"/>
           </a:xfrm>
           <a:prstGeom prst="rect">
@@ -4501,7 +4505,9 @@
           <a:ln/>
         </p:spPr>
         <p:txBody>
-          <a:bodyPr wrap="square" lIns="0" tIns="0" rIns="0" bIns="0" rtlCol="0" anchor="ctr"/>
+          <a:bodyPr wrap="square" lIns="0" tIns="0" rIns="0" bIns="0" rtlCol="0" anchor="ctr">
+            <a:normAutofit/>
+          </a:bodyPr>
           <a:lstStyle/>
           <a:p>
             <a:pPr indent="0" marL="0">
@@ -4530,17 +4536,19 @@
         </p:nvSpPr>
         <p:spPr>
           <a:xfrm>
-            <a:off x="502920" y="1188720"/>
-            <a:ext cx="11057839" cy="457200"/>
-          </a:xfrm>
-          <a:prstGeom prst="rect">
-            <a:avLst/>
-          </a:prstGeom>
-          <a:noFill/>
-          <a:ln/>
-        </p:spPr>
-        <p:txBody>
-          <a:bodyPr wrap="square" rtlCol="0" anchor="ctr"/>
+            <a:off x="566928" y="1188720"/>
+            <a:ext cx="11057839" cy="219075"/>
+          </a:xfrm>
+          <a:prstGeom prst="rect">
+            <a:avLst/>
+          </a:prstGeom>
+          <a:noFill/>
+          <a:ln/>
+        </p:spPr>
+        <p:txBody>
+          <a:bodyPr wrap="square" lIns="0" tIns="0" rIns="0" bIns="0" rtlCol="0" anchor="ctr">
+            <a:normAutofit/>
+          </a:bodyPr>
           <a:lstStyle/>
           <a:p>
             <a:pPr indent="0" marL="0">
@@ -4569,7 +4577,7 @@
         </p:nvSpPr>
         <p:spPr>
           <a:xfrm>
-            <a:off x="502920" y="1691640"/>
+            <a:off x="566928" y="1480947"/>
             <a:ext cx="11057839" cy="0"/>
           </a:xfrm>
           <a:prstGeom prst="line">
@@ -4592,7 +4600,7 @@
         </p:nvSpPr>
         <p:spPr>
           <a:xfrm>
-            <a:off x="502920" y="1965960"/>
+            <a:off x="566928" y="1618107"/>
             <a:ext cx="2641016" cy="960120"/>
           </a:xfrm>
           <a:prstGeom prst="roundRect">
@@ -4619,7 +4627,7 @@
         </p:nvSpPr>
         <p:spPr>
           <a:xfrm>
-            <a:off x="667512" y="2093976"/>
+            <a:off x="731520" y="1746123"/>
             <a:ext cx="2311832" cy="201168"/>
           </a:xfrm>
           <a:prstGeom prst="rect">
@@ -4629,7 +4637,9 @@
           <a:ln/>
         </p:spPr>
         <p:txBody>
-          <a:bodyPr wrap="square" lIns="0" tIns="0" rIns="0" bIns="0" rtlCol="0" anchor="ctr"/>
+          <a:bodyPr wrap="square" lIns="0" tIns="0" rIns="0" bIns="0" rtlCol="0" anchor="ctr">
+            <a:normAutofit/>
+          </a:bodyPr>
           <a:lstStyle/>
           <a:p>
             <a:pPr indent="0" marL="0">
@@ -4658,8 +4668,8 @@
         </p:nvSpPr>
         <p:spPr>
           <a:xfrm>
-            <a:off x="667512" y="2313432"/>
-            <a:ext cx="2311832" cy="274320"/>
+            <a:off x="731520" y="1965579"/>
+            <a:ext cx="2311832" cy="279400"/>
           </a:xfrm>
           <a:prstGeom prst="rect">
             <a:avLst/>
@@ -4702,7 +4712,7 @@
         </p:nvSpPr>
         <p:spPr>
           <a:xfrm>
-            <a:off x="3308528" y="1965960"/>
+            <a:off x="3372536" y="1618107"/>
             <a:ext cx="2641016" cy="960120"/>
           </a:xfrm>
           <a:prstGeom prst="roundRect">
@@ -4729,7 +4739,7 @@
         </p:nvSpPr>
         <p:spPr>
           <a:xfrm>
-            <a:off x="3473120" y="2093976"/>
+            <a:off x="3537128" y="1746123"/>
             <a:ext cx="2311832" cy="201168"/>
           </a:xfrm>
           <a:prstGeom prst="rect">
@@ -4739,7 +4749,9 @@
           <a:ln/>
         </p:spPr>
         <p:txBody>
-          <a:bodyPr wrap="square" lIns="0" tIns="0" rIns="0" bIns="0" rtlCol="0" anchor="ctr"/>
+          <a:bodyPr wrap="square" lIns="0" tIns="0" rIns="0" bIns="0" rtlCol="0" anchor="ctr">
+            <a:normAutofit/>
+          </a:bodyPr>
           <a:lstStyle/>
           <a:p>
             <a:pPr indent="0" marL="0">
@@ -4768,8 +4780,8 @@
         </p:nvSpPr>
         <p:spPr>
           <a:xfrm>
-            <a:off x="3473120" y="2313432"/>
-            <a:ext cx="2311832" cy="274320"/>
+            <a:off x="3537128" y="1965579"/>
+            <a:ext cx="2311832" cy="279400"/>
           </a:xfrm>
           <a:prstGeom prst="rect">
             <a:avLst/>
@@ -4812,7 +4824,7 @@
         </p:nvSpPr>
         <p:spPr>
           <a:xfrm>
-            <a:off x="6114136" y="1965960"/>
+            <a:off x="6178144" y="1618107"/>
             <a:ext cx="2641016" cy="960120"/>
           </a:xfrm>
           <a:prstGeom prst="roundRect">
@@ -4839,7 +4851,7 @@
         </p:nvSpPr>
         <p:spPr>
           <a:xfrm>
-            <a:off x="6278728" y="2093976"/>
+            <a:off x="6342736" y="1746123"/>
             <a:ext cx="2311832" cy="201168"/>
           </a:xfrm>
           <a:prstGeom prst="rect">
@@ -4849,7 +4861,9 @@
           <a:ln/>
         </p:spPr>
         <p:txBody>
-          <a:bodyPr wrap="square" lIns="0" tIns="0" rIns="0" bIns="0" rtlCol="0" anchor="ctr"/>
+          <a:bodyPr wrap="square" lIns="0" tIns="0" rIns="0" bIns="0" rtlCol="0" anchor="ctr">
+            <a:normAutofit/>
+          </a:bodyPr>
           <a:lstStyle/>
           <a:p>
             <a:pPr indent="0" marL="0">
@@ -4878,8 +4892,8 @@
         </p:nvSpPr>
         <p:spPr>
           <a:xfrm>
-            <a:off x="6278728" y="2313432"/>
-            <a:ext cx="2311832" cy="274320"/>
+            <a:off x="6342736" y="1965579"/>
+            <a:ext cx="2311832" cy="279400"/>
           </a:xfrm>
           <a:prstGeom prst="rect">
             <a:avLst/>
@@ -4900,7 +4914,7 @@
               <a:buNone/>
             </a:pPr>
             <a:r>
-              <a:rPr lang="en-US" sz="1800" b="1" dirty="0">
+              <a:rPr lang="en-US" sz="2200" b="1" dirty="0">
                 <a:solidFill>
                   <a:srgbClr val="10161F"/>
                 </a:solidFill>
@@ -4910,7 +4924,7 @@
               </a:rPr>
               <a:t>제3종일반주거</a:t>
             </a:r>
-            <a:endParaRPr lang="en-US" sz="1800" dirty="0"/>
+            <a:endParaRPr lang="en-US" sz="2200" dirty="0"/>
           </a:p>
         </p:txBody>
       </p:sp>
@@ -4922,7 +4936,7 @@
         </p:nvSpPr>
         <p:spPr>
           <a:xfrm>
-            <a:off x="8919743" y="1965960"/>
+            <a:off x="8983751" y="1618107"/>
             <a:ext cx="2641016" cy="960120"/>
           </a:xfrm>
           <a:prstGeom prst="roundRect">
@@ -4949,7 +4963,7 @@
         </p:nvSpPr>
         <p:spPr>
           <a:xfrm>
-            <a:off x="9084335" y="2093976"/>
+            <a:off x="9148343" y="1746123"/>
             <a:ext cx="2311832" cy="201168"/>
           </a:xfrm>
           <a:prstGeom prst="rect">
@@ -4959,7 +4973,9 @@
           <a:ln/>
         </p:spPr>
         <p:txBody>
-          <a:bodyPr wrap="square" lIns="0" tIns="0" rIns="0" bIns="0" rtlCol="0" anchor="ctr"/>
+          <a:bodyPr wrap="square" lIns="0" tIns="0" rIns="0" bIns="0" rtlCol="0" anchor="ctr">
+            <a:normAutofit/>
+          </a:bodyPr>
           <a:lstStyle/>
           <a:p>
             <a:pPr indent="0" marL="0">
@@ -4988,8 +5004,8 @@
         </p:nvSpPr>
         <p:spPr>
           <a:xfrm>
-            <a:off x="9084335" y="2313432"/>
-            <a:ext cx="2311832" cy="274320"/>
+            <a:off x="9148343" y="1965579"/>
+            <a:ext cx="2311832" cy="279400"/>
           </a:xfrm>
           <a:prstGeom prst="rect">
             <a:avLst/>
@@ -5032,7 +5048,7 @@
         </p:nvSpPr>
         <p:spPr>
           <a:xfrm>
-            <a:off x="502920" y="3090672"/>
+            <a:off x="566928" y="2742819"/>
             <a:ext cx="2641016" cy="960120"/>
           </a:xfrm>
           <a:prstGeom prst="roundRect">
@@ -5059,7 +5075,7 @@
         </p:nvSpPr>
         <p:spPr>
           <a:xfrm>
-            <a:off x="667512" y="3218688"/>
+            <a:off x="731520" y="2870835"/>
             <a:ext cx="2311832" cy="201168"/>
           </a:xfrm>
           <a:prstGeom prst="rect">
@@ -5069,7 +5085,9 @@
           <a:ln/>
         </p:spPr>
         <p:txBody>
-          <a:bodyPr wrap="square" lIns="0" tIns="0" rIns="0" bIns="0" rtlCol="0" anchor="ctr"/>
+          <a:bodyPr wrap="square" lIns="0" tIns="0" rIns="0" bIns="0" rtlCol="0" anchor="ctr">
+            <a:normAutofit/>
+          </a:bodyPr>
           <a:lstStyle/>
           <a:p>
             <a:pPr indent="0" marL="0">
@@ -5098,8 +5116,8 @@
         </p:nvSpPr>
         <p:spPr>
           <a:xfrm>
-            <a:off x="667512" y="3438144"/>
-            <a:ext cx="2311832" cy="274320"/>
+            <a:off x="731520" y="3090291"/>
+            <a:ext cx="2311832" cy="279400"/>
           </a:xfrm>
           <a:prstGeom prst="rect">
             <a:avLst/>
@@ -5142,7 +5160,7 @@
         </p:nvSpPr>
         <p:spPr>
           <a:xfrm>
-            <a:off x="3308528" y="3090672"/>
+            <a:off x="3372536" y="2742819"/>
             <a:ext cx="2641016" cy="960120"/>
           </a:xfrm>
           <a:prstGeom prst="roundRect">
@@ -5169,7 +5187,7 @@
         </p:nvSpPr>
         <p:spPr>
           <a:xfrm>
-            <a:off x="3473120" y="3218688"/>
+            <a:off x="3537128" y="2870835"/>
             <a:ext cx="2311832" cy="201168"/>
           </a:xfrm>
           <a:prstGeom prst="rect">
@@ -5179,7 +5197,9 @@
           <a:ln/>
         </p:spPr>
         <p:txBody>
-          <a:bodyPr wrap="square" lIns="0" tIns="0" rIns="0" bIns="0" rtlCol="0" anchor="ctr"/>
+          <a:bodyPr wrap="square" lIns="0" tIns="0" rIns="0" bIns="0" rtlCol="0" anchor="ctr">
+            <a:normAutofit/>
+          </a:bodyPr>
           <a:lstStyle/>
           <a:p>
             <a:pPr indent="0" marL="0">
@@ -5208,8 +5228,8 @@
         </p:nvSpPr>
         <p:spPr>
           <a:xfrm>
-            <a:off x="3473120" y="3438144"/>
-            <a:ext cx="2311832" cy="274320"/>
+            <a:off x="3537128" y="3090291"/>
+            <a:ext cx="2311832" cy="279400"/>
           </a:xfrm>
           <a:prstGeom prst="rect">
             <a:avLst/>
@@ -5252,7 +5272,7 @@
         </p:nvSpPr>
         <p:spPr>
           <a:xfrm>
-            <a:off x="6114136" y="3090672"/>
+            <a:off x="6178144" y="2742819"/>
             <a:ext cx="2641016" cy="960120"/>
           </a:xfrm>
           <a:prstGeom prst="roundRect">
@@ -5279,7 +5299,7 @@
         </p:nvSpPr>
         <p:spPr>
           <a:xfrm>
-            <a:off x="6278728" y="3218688"/>
+            <a:off x="6342736" y="2870835"/>
             <a:ext cx="2311832" cy="201168"/>
           </a:xfrm>
           <a:prstGeom prst="rect">
@@ -5289,7 +5309,9 @@
           <a:ln/>
         </p:spPr>
         <p:txBody>
-          <a:bodyPr wrap="square" lIns="0" tIns="0" rIns="0" bIns="0" rtlCol="0" anchor="ctr"/>
+          <a:bodyPr wrap="square" lIns="0" tIns="0" rIns="0" bIns="0" rtlCol="0" anchor="ctr">
+            <a:normAutofit/>
+          </a:bodyPr>
           <a:lstStyle/>
           <a:p>
             <a:pPr indent="0" marL="0">
@@ -5318,8 +5340,8 @@
         </p:nvSpPr>
         <p:spPr>
           <a:xfrm>
-            <a:off x="6278728" y="3438144"/>
-            <a:ext cx="2311832" cy="274320"/>
+            <a:off x="6342736" y="3090291"/>
+            <a:ext cx="2311832" cy="279400"/>
           </a:xfrm>
           <a:prstGeom prst="rect">
             <a:avLst/>
@@ -5362,7 +5384,7 @@
         </p:nvSpPr>
         <p:spPr>
           <a:xfrm>
-            <a:off x="502920" y="4306824"/>
+            <a:off x="566928" y="3958971"/>
             <a:ext cx="11057839" cy="274320"/>
           </a:xfrm>
           <a:prstGeom prst="rect">
@@ -5401,12 +5423,12 @@
         </p:nvSpPr>
         <p:spPr>
           <a:xfrm>
-            <a:off x="502920" y="4636008"/>
-            <a:ext cx="11057839" cy="396240"/>
+            <a:off x="566928" y="4288155"/>
+            <a:ext cx="11057839" cy="512191"/>
           </a:xfrm>
           <a:prstGeom prst="roundRect">
             <a:avLst>
-              <a:gd name="adj" fmla="val 11538"/>
+              <a:gd name="adj" fmla="val 8926"/>
             </a:avLst>
           </a:prstGeom>
           <a:solidFill>
@@ -5428,12 +5450,12 @@
         </p:nvSpPr>
         <p:spPr>
           <a:xfrm>
-            <a:off x="612648" y="4709160"/>
-            <a:ext cx="411480" cy="249936"/>
+            <a:off x="676656" y="4361371"/>
+            <a:ext cx="411480" cy="365760"/>
           </a:xfrm>
           <a:prstGeom prst="roundRect">
             <a:avLst>
-              <a:gd name="adj" fmla="val 14634"/>
+              <a:gd name="adj" fmla="val 10000"/>
             </a:avLst>
           </a:prstGeom>
           <a:solidFill>
@@ -5455,8 +5477,8 @@
         </p:nvSpPr>
         <p:spPr>
           <a:xfrm>
-            <a:off x="612648" y="4709160"/>
-            <a:ext cx="411480" cy="249936"/>
+            <a:off x="676656" y="4361371"/>
+            <a:ext cx="411480" cy="365760"/>
           </a:xfrm>
           <a:prstGeom prst="rect">
             <a:avLst/>
@@ -5494,8 +5516,8 @@
         </p:nvSpPr>
         <p:spPr>
           <a:xfrm>
-            <a:off x="1143000" y="4672584"/>
-            <a:ext cx="10280599" cy="323088"/>
+            <a:off x="1207008" y="4324731"/>
+            <a:ext cx="10280599" cy="439039"/>
           </a:xfrm>
           <a:prstGeom prst="rect">
             <a:avLst/>
@@ -5511,7 +5533,7 @@
               <a:buNone/>
             </a:pPr>
             <a:r>
-              <a:rPr lang="en-US" sz="1000" dirty="0">
+              <a:rPr lang="en-US" sz="1150" dirty="0">
                 <a:solidFill>
                   <a:srgbClr val="10161F"/>
                 </a:solidFill>
@@ -5521,7 +5543,7 @@
               </a:rPr>
               <a:t>입지 가치: 대중교통 역세권 입지, 해당 권역 업무·상업 중심지 배후 수요 확보</a:t>
             </a:r>
-            <a:endParaRPr lang="en-US" sz="1000" dirty="0"/>
+            <a:endParaRPr lang="en-US" sz="1150" dirty="0"/>
           </a:p>
         </p:txBody>
       </p:sp>
@@ -5533,12 +5555,12 @@
         </p:nvSpPr>
         <p:spPr>
           <a:xfrm>
-            <a:off x="502920" y="5114544"/>
-            <a:ext cx="11057839" cy="396240"/>
+            <a:off x="566928" y="4882642"/>
+            <a:ext cx="11057839" cy="512191"/>
           </a:xfrm>
           <a:prstGeom prst="roundRect">
             <a:avLst>
-              <a:gd name="adj" fmla="val 11538"/>
+              <a:gd name="adj" fmla="val 8926"/>
             </a:avLst>
           </a:prstGeom>
           <a:solidFill>
@@ -5560,12 +5582,12 @@
         </p:nvSpPr>
         <p:spPr>
           <a:xfrm>
-            <a:off x="612648" y="5187696"/>
-            <a:ext cx="411480" cy="249936"/>
+            <a:off x="676656" y="4955858"/>
+            <a:ext cx="411480" cy="365760"/>
           </a:xfrm>
           <a:prstGeom prst="roundRect">
             <a:avLst>
-              <a:gd name="adj" fmla="val 14634"/>
+              <a:gd name="adj" fmla="val 10000"/>
             </a:avLst>
           </a:prstGeom>
           <a:solidFill>
@@ -5587,8 +5609,8 @@
         </p:nvSpPr>
         <p:spPr>
           <a:xfrm>
-            <a:off x="612648" y="5187696"/>
-            <a:ext cx="411480" cy="249936"/>
+            <a:off x="676656" y="4955858"/>
+            <a:ext cx="411480" cy="365760"/>
           </a:xfrm>
           <a:prstGeom prst="rect">
             <a:avLst/>
@@ -5626,8 +5648,8 @@
         </p:nvSpPr>
         <p:spPr>
           <a:xfrm>
-            <a:off x="1143000" y="5151120"/>
-            <a:ext cx="10280599" cy="323088"/>
+            <a:off x="1207008" y="4919218"/>
+            <a:ext cx="10280599" cy="439039"/>
           </a:xfrm>
           <a:prstGeom prst="rect">
             <a:avLst/>
@@ -5643,7 +5665,7 @@
               <a:buNone/>
             </a:pPr>
             <a:r>
-              <a:rPr lang="en-US" sz="1000" dirty="0">
+              <a:rPr lang="en-US" sz="1150" dirty="0">
                 <a:solidFill>
                   <a:srgbClr val="10161F"/>
                 </a:solidFill>
@@ -5653,7 +5675,7 @@
               </a:rPr>
               <a:t>자산 규모: 해당 권역 소재 단독 빌딩 매입 기회</a:t>
             </a:r>
-            <a:endParaRPr lang="en-US" sz="1000" dirty="0"/>
+            <a:endParaRPr lang="en-US" sz="1150" dirty="0"/>
           </a:p>
         </p:txBody>
       </p:sp>
@@ -5665,12 +5687,12 @@
         </p:nvSpPr>
         <p:spPr>
           <a:xfrm>
-            <a:off x="502920" y="5593080"/>
-            <a:ext cx="11057839" cy="396240"/>
+            <a:off x="566928" y="5477129"/>
+            <a:ext cx="11057839" cy="512191"/>
           </a:xfrm>
           <a:prstGeom prst="roundRect">
             <a:avLst>
-              <a:gd name="adj" fmla="val 11538"/>
+              <a:gd name="adj" fmla="val 8926"/>
             </a:avLst>
           </a:prstGeom>
           <a:solidFill>
@@ -5692,12 +5714,12 @@
         </p:nvSpPr>
         <p:spPr>
           <a:xfrm>
-            <a:off x="612648" y="5666232"/>
-            <a:ext cx="411480" cy="249936"/>
+            <a:off x="676656" y="5550345"/>
+            <a:ext cx="411480" cy="365760"/>
           </a:xfrm>
           <a:prstGeom prst="roundRect">
             <a:avLst>
-              <a:gd name="adj" fmla="val 14634"/>
+              <a:gd name="adj" fmla="val 10000"/>
             </a:avLst>
           </a:prstGeom>
           <a:solidFill>
@@ -5719,8 +5741,8 @@
         </p:nvSpPr>
         <p:spPr>
           <a:xfrm>
-            <a:off x="612648" y="5666232"/>
-            <a:ext cx="411480" cy="249936"/>
+            <a:off x="676656" y="5550345"/>
+            <a:ext cx="411480" cy="365760"/>
           </a:xfrm>
           <a:prstGeom prst="rect">
             <a:avLst/>
@@ -5758,8 +5780,8 @@
         </p:nvSpPr>
         <p:spPr>
           <a:xfrm>
-            <a:off x="1143000" y="5629656"/>
-            <a:ext cx="10280599" cy="323088"/>
+            <a:off x="1207008" y="5513705"/>
+            <a:ext cx="10280599" cy="439039"/>
           </a:xfrm>
           <a:prstGeom prst="rect">
             <a:avLst/>
@@ -5775,7 +5797,7 @@
               <a:buNone/>
             </a:pPr>
             <a:r>
-              <a:rPr lang="en-US" sz="1000" dirty="0">
+              <a:rPr lang="en-US" sz="1150" dirty="0">
                 <a:solidFill>
                   <a:srgbClr val="10161F"/>
                 </a:solidFill>
@@ -5785,7 +5807,7 @@
               </a:rPr>
               <a:t>수익 안정성: 안정적 임대수익 기반 투자 매물</a:t>
             </a:r>
-            <a:endParaRPr lang="en-US" sz="1000" dirty="0"/>
+            <a:endParaRPr lang="en-US" sz="1150" dirty="0"/>
           </a:p>
         </p:txBody>
       </p:sp>
@@ -5797,7 +5819,7 @@
         </p:nvSpPr>
         <p:spPr>
           <a:xfrm>
-            <a:off x="502920" y="6382512"/>
+            <a:off x="566928" y="6382512"/>
             <a:ext cx="7315200" cy="219456"/>
           </a:xfrm>
           <a:prstGeom prst="rect">
@@ -5836,7 +5858,7 @@
         </p:nvSpPr>
         <p:spPr>
           <a:xfrm>
-            <a:off x="10774375" y="6382512"/>
+            <a:off x="10710367" y="6382512"/>
             <a:ext cx="914400" cy="219456"/>
           </a:xfrm>
           <a:prstGeom prst="rect">
@@ -5907,7 +5929,7 @@
         </p:nvSpPr>
         <p:spPr>
           <a:xfrm>
-            <a:off x="502920" y="457200"/>
+            <a:off x="566928" y="457200"/>
             <a:ext cx="384048" cy="384048"/>
           </a:xfrm>
           <a:prstGeom prst="ellipse">
@@ -5927,7 +5949,7 @@
         </p:nvSpPr>
         <p:spPr>
           <a:xfrm>
-            <a:off x="502920" y="457200"/>
+            <a:off x="566928" y="457200"/>
             <a:ext cx="384048" cy="384048"/>
           </a:xfrm>
           <a:prstGeom prst="rect">
@@ -5966,7 +5988,7 @@
         </p:nvSpPr>
         <p:spPr>
           <a:xfrm>
-            <a:off x="1069848" y="457200"/>
+            <a:off x="1133856" y="457200"/>
             <a:ext cx="10490911" cy="182880"/>
           </a:xfrm>
           <a:prstGeom prst="rect">
@@ -6005,7 +6027,7 @@
         </p:nvSpPr>
         <p:spPr>
           <a:xfrm>
-            <a:off x="1069848" y="640080"/>
+            <a:off x="1133856" y="640080"/>
             <a:ext cx="10490911" cy="365760"/>
           </a:xfrm>
           <a:prstGeom prst="rect">
@@ -6015,7 +6037,9 @@
           <a:ln/>
         </p:spPr>
         <p:txBody>
-          <a:bodyPr wrap="square" lIns="0" tIns="0" rIns="0" bIns="0" rtlCol="0" anchor="ctr"/>
+          <a:bodyPr wrap="square" lIns="0" tIns="0" rIns="0" bIns="0" rtlCol="0" anchor="ctr">
+            <a:normAutofit/>
+          </a:bodyPr>
           <a:lstStyle/>
           <a:p>
             <a:pPr indent="0" marL="0">
@@ -6052,7 +6076,7 @@
         </p:blipFill>
         <p:spPr>
           <a:xfrm>
-            <a:off x="502920" y="1481328"/>
+            <a:off x="566928" y="1481328"/>
             <a:ext cx="5120640" cy="4114800"/>
           </a:xfrm>
           <a:prstGeom prst="rect">
@@ -6068,7 +6092,7 @@
         </p:nvSpPr>
         <p:spPr>
           <a:xfrm>
-            <a:off x="5989320" y="1481328"/>
+            <a:off x="6053328" y="1481328"/>
             <a:ext cx="1560003" cy="457200"/>
           </a:xfrm>
           <a:prstGeom prst="rect">
@@ -6078,7 +6102,9 @@
           <a:ln/>
         </p:spPr>
         <p:txBody>
-          <a:bodyPr wrap="square" lIns="0" tIns="0" rIns="0" bIns="0" rtlCol="0" anchor="ctr"/>
+          <a:bodyPr wrap="square" lIns="0" tIns="0" rIns="0" bIns="0" rtlCol="0" anchor="ctr">
+            <a:normAutofit/>
+          </a:bodyPr>
           <a:lstStyle/>
           <a:p>
             <a:pPr indent="0" marL="0">
@@ -6110,7 +6136,7 @@
         </p:nvSpPr>
         <p:spPr>
           <a:xfrm>
-            <a:off x="7549323" y="1481328"/>
+            <a:off x="7613331" y="1481328"/>
             <a:ext cx="4011436" cy="457200"/>
           </a:xfrm>
           <a:prstGeom prst="rect">
@@ -6120,7 +6146,9 @@
           <a:ln/>
         </p:spPr>
         <p:txBody>
-          <a:bodyPr wrap="square" lIns="0" tIns="0" rIns="0" bIns="0" rtlCol="0" anchor="ctr"/>
+          <a:bodyPr wrap="square" lIns="0" tIns="0" rIns="0" bIns="0" rtlCol="0" anchor="ctr">
+            <a:normAutofit/>
+          </a:bodyPr>
           <a:lstStyle/>
           <a:p>
             <a:pPr indent="0" marL="0">
@@ -6152,7 +6180,7 @@
         </p:nvSpPr>
         <p:spPr>
           <a:xfrm>
-            <a:off x="5989320" y="1938528"/>
+            <a:off x="6053328" y="1938528"/>
             <a:ext cx="5571439" cy="0"/>
           </a:xfrm>
           <a:prstGeom prst="line">
@@ -6175,7 +6203,7 @@
         </p:nvSpPr>
         <p:spPr>
           <a:xfrm>
-            <a:off x="5989320" y="1938528"/>
+            <a:off x="6053328" y="1938528"/>
             <a:ext cx="1560003" cy="457200"/>
           </a:xfrm>
           <a:prstGeom prst="rect">
@@ -6185,7 +6213,9 @@
           <a:ln/>
         </p:spPr>
         <p:txBody>
-          <a:bodyPr wrap="square" lIns="0" tIns="0" rIns="0" bIns="0" rtlCol="0" anchor="ctr"/>
+          <a:bodyPr wrap="square" lIns="0" tIns="0" rIns="0" bIns="0" rtlCol="0" anchor="ctr">
+            <a:normAutofit/>
+          </a:bodyPr>
           <a:lstStyle/>
           <a:p>
             <a:pPr indent="0" marL="0">
@@ -6217,7 +6247,7 @@
         </p:nvSpPr>
         <p:spPr>
           <a:xfrm>
-            <a:off x="7549323" y="1938528"/>
+            <a:off x="7613331" y="1938528"/>
             <a:ext cx="4011436" cy="457200"/>
           </a:xfrm>
           <a:prstGeom prst="rect">
@@ -6227,7 +6257,9 @@
           <a:ln/>
         </p:spPr>
         <p:txBody>
-          <a:bodyPr wrap="square" lIns="0" tIns="0" rIns="0" bIns="0" rtlCol="0" anchor="ctr"/>
+          <a:bodyPr wrap="square" lIns="0" tIns="0" rIns="0" bIns="0" rtlCol="0" anchor="ctr">
+            <a:normAutofit/>
+          </a:bodyPr>
           <a:lstStyle/>
           <a:p>
             <a:pPr indent="0" marL="0">
@@ -6259,7 +6291,7 @@
         </p:nvSpPr>
         <p:spPr>
           <a:xfrm>
-            <a:off x="5989320" y="2505456"/>
+            <a:off x="6053328" y="2505456"/>
             <a:ext cx="5571439" cy="658368"/>
           </a:xfrm>
           <a:prstGeom prst="roundRect">
@@ -6281,7 +6313,7 @@
         </p:nvSpPr>
         <p:spPr>
           <a:xfrm>
-            <a:off x="5989320" y="2560320"/>
+            <a:off x="6053328" y="2560320"/>
             <a:ext cx="36576" cy="548640"/>
           </a:xfrm>
           <a:prstGeom prst="rect">
@@ -6301,7 +6333,7 @@
         </p:nvSpPr>
         <p:spPr>
           <a:xfrm>
-            <a:off x="6135624" y="2596896"/>
+            <a:off x="6199632" y="2596896"/>
             <a:ext cx="5315407" cy="201168"/>
           </a:xfrm>
           <a:prstGeom prst="rect">
@@ -6340,7 +6372,7 @@
         </p:nvSpPr>
         <p:spPr>
           <a:xfrm>
-            <a:off x="6135624" y="2798064"/>
+            <a:off x="6199632" y="2798064"/>
             <a:ext cx="5315407" cy="329184"/>
           </a:xfrm>
           <a:prstGeom prst="rect">
@@ -6383,7 +6415,7 @@
         </p:nvSpPr>
         <p:spPr>
           <a:xfrm>
-            <a:off x="502920" y="6382512"/>
+            <a:off x="566928" y="6382512"/>
             <a:ext cx="7315200" cy="219456"/>
           </a:xfrm>
           <a:prstGeom prst="rect">
@@ -6422,7 +6454,7 @@
         </p:nvSpPr>
         <p:spPr>
           <a:xfrm>
-            <a:off x="10774375" y="6382512"/>
+            <a:off x="10710367" y="6382512"/>
             <a:ext cx="914400" cy="219456"/>
           </a:xfrm>
           <a:prstGeom prst="rect">
@@ -6493,7 +6525,7 @@
         </p:nvSpPr>
         <p:spPr>
           <a:xfrm>
-            <a:off x="502920" y="457200"/>
+            <a:off x="566928" y="457200"/>
             <a:ext cx="384048" cy="384048"/>
           </a:xfrm>
           <a:prstGeom prst="ellipse">
@@ -6513,7 +6545,7 @@
         </p:nvSpPr>
         <p:spPr>
           <a:xfrm>
-            <a:off x="502920" y="457200"/>
+            <a:off x="566928" y="457200"/>
             <a:ext cx="384048" cy="384048"/>
           </a:xfrm>
           <a:prstGeom prst="rect">
@@ -6552,7 +6584,7 @@
         </p:nvSpPr>
         <p:spPr>
           <a:xfrm>
-            <a:off x="1069848" y="457200"/>
+            <a:off x="1133856" y="457200"/>
             <a:ext cx="10490911" cy="182880"/>
           </a:xfrm>
           <a:prstGeom prst="rect">
@@ -6591,7 +6623,7 @@
         </p:nvSpPr>
         <p:spPr>
           <a:xfrm>
-            <a:off x="1069848" y="640080"/>
+            <a:off x="1133856" y="640080"/>
             <a:ext cx="10490911" cy="365760"/>
           </a:xfrm>
           <a:prstGeom prst="rect">
@@ -6601,7 +6633,9 @@
           <a:ln/>
         </p:spPr>
         <p:txBody>
-          <a:bodyPr wrap="square" lIns="0" tIns="0" rIns="0" bIns="0" rtlCol="0" anchor="ctr"/>
+          <a:bodyPr wrap="square" lIns="0" tIns="0" rIns="0" bIns="0" rtlCol="0" anchor="ctr">
+            <a:normAutofit/>
+          </a:bodyPr>
           <a:lstStyle/>
           <a:p>
             <a:pPr indent="0" marL="0">
@@ -6630,7 +6664,7 @@
         </p:nvSpPr>
         <p:spPr>
           <a:xfrm>
-            <a:off x="502920" y="1371600"/>
+            <a:off x="566928" y="1371600"/>
             <a:ext cx="6858000" cy="237744"/>
           </a:xfrm>
           <a:prstGeom prst="rect">
@@ -6669,7 +6703,7 @@
         </p:nvSpPr>
         <p:spPr>
           <a:xfrm>
-            <a:off x="502920" y="1645920"/>
+            <a:off x="566928" y="1645920"/>
             <a:ext cx="1920240" cy="402336"/>
           </a:xfrm>
           <a:prstGeom prst="rect">
@@ -6679,7 +6713,9 @@
           <a:ln/>
         </p:spPr>
         <p:txBody>
-          <a:bodyPr wrap="square" lIns="0" tIns="0" rIns="0" bIns="0" rtlCol="0" anchor="ctr"/>
+          <a:bodyPr wrap="square" lIns="0" tIns="0" rIns="0" bIns="0" rtlCol="0" anchor="ctr">
+            <a:normAutofit/>
+          </a:bodyPr>
           <a:lstStyle/>
           <a:p>
             <a:pPr indent="0" marL="0">
@@ -6711,7 +6747,7 @@
         </p:nvSpPr>
         <p:spPr>
           <a:xfrm>
-            <a:off x="2423160" y="1645920"/>
+            <a:off x="2487168" y="1645920"/>
             <a:ext cx="4937760" cy="402336"/>
           </a:xfrm>
           <a:prstGeom prst="rect">
@@ -6721,7 +6757,9 @@
           <a:ln/>
         </p:spPr>
         <p:txBody>
-          <a:bodyPr wrap="square" lIns="0" tIns="0" rIns="0" bIns="0" rtlCol="0" anchor="ctr"/>
+          <a:bodyPr wrap="square" lIns="0" tIns="0" rIns="0" bIns="0" rtlCol="0" anchor="ctr">
+            <a:normAutofit/>
+          </a:bodyPr>
           <a:lstStyle/>
           <a:p>
             <a:pPr indent="0" marL="0">
@@ -6753,7 +6791,7 @@
         </p:nvSpPr>
         <p:spPr>
           <a:xfrm>
-            <a:off x="502920" y="2048256"/>
+            <a:off x="566928" y="2048256"/>
             <a:ext cx="6858000" cy="0"/>
           </a:xfrm>
           <a:prstGeom prst="line">
@@ -6776,7 +6814,7 @@
         </p:nvSpPr>
         <p:spPr>
           <a:xfrm>
-            <a:off x="502920" y="2048256"/>
+            <a:off x="566928" y="2048256"/>
             <a:ext cx="1920240" cy="402336"/>
           </a:xfrm>
           <a:prstGeom prst="rect">
@@ -6786,7 +6824,9 @@
           <a:ln/>
         </p:spPr>
         <p:txBody>
-          <a:bodyPr wrap="square" lIns="0" tIns="0" rIns="0" bIns="0" rtlCol="0" anchor="ctr"/>
+          <a:bodyPr wrap="square" lIns="0" tIns="0" rIns="0" bIns="0" rtlCol="0" anchor="ctr">
+            <a:normAutofit/>
+          </a:bodyPr>
           <a:lstStyle/>
           <a:p>
             <a:pPr indent="0" marL="0">
@@ -6818,7 +6858,7 @@
         </p:nvSpPr>
         <p:spPr>
           <a:xfrm>
-            <a:off x="2423160" y="2048256"/>
+            <a:off x="2487168" y="2048256"/>
             <a:ext cx="4937760" cy="402336"/>
           </a:xfrm>
           <a:prstGeom prst="rect">
@@ -6828,7 +6868,9 @@
           <a:ln/>
         </p:spPr>
         <p:txBody>
-          <a:bodyPr wrap="square" lIns="0" tIns="0" rIns="0" bIns="0" rtlCol="0" anchor="ctr"/>
+          <a:bodyPr wrap="square" lIns="0" tIns="0" rIns="0" bIns="0" rtlCol="0" anchor="ctr">
+            <a:normAutofit/>
+          </a:bodyPr>
           <a:lstStyle/>
           <a:p>
             <a:pPr indent="0" marL="0">
@@ -6860,7 +6902,7 @@
         </p:nvSpPr>
         <p:spPr>
           <a:xfrm>
-            <a:off x="7540600" y="1371600"/>
+            <a:off x="7604608" y="1371600"/>
             <a:ext cx="0" cy="4754880"/>
           </a:xfrm>
           <a:prstGeom prst="line">
@@ -6883,7 +6925,7 @@
         </p:nvSpPr>
         <p:spPr>
           <a:xfrm>
-            <a:off x="7720279" y="1645920"/>
+            <a:off x="7784287" y="1645920"/>
             <a:ext cx="3840480" cy="2103120"/>
           </a:xfrm>
           <a:prstGeom prst="roundRect">
@@ -6905,7 +6947,7 @@
         </p:nvSpPr>
         <p:spPr>
           <a:xfrm>
-            <a:off x="7720279" y="1700784"/>
+            <a:off x="7784287" y="1700784"/>
             <a:ext cx="36576" cy="1993392"/>
           </a:xfrm>
           <a:prstGeom prst="rect">
@@ -6925,7 +6967,7 @@
         </p:nvSpPr>
         <p:spPr>
           <a:xfrm>
-            <a:off x="7866583" y="1737360"/>
+            <a:off x="7930591" y="1737360"/>
             <a:ext cx="3584448" cy="201168"/>
           </a:xfrm>
           <a:prstGeom prst="rect">
@@ -6964,7 +7006,7 @@
         </p:nvSpPr>
         <p:spPr>
           <a:xfrm>
-            <a:off x="7866583" y="1938528"/>
+            <a:off x="7930591" y="1938528"/>
             <a:ext cx="3584448" cy="1773936"/>
           </a:xfrm>
           <a:prstGeom prst="rect">
@@ -7007,7 +7049,7 @@
         </p:nvSpPr>
         <p:spPr>
           <a:xfrm>
-            <a:off x="7720279" y="3977640"/>
+            <a:off x="7784287" y="3977640"/>
             <a:ext cx="3840480" cy="2148840"/>
           </a:xfrm>
           <a:prstGeom prst="roundRect">
@@ -7029,7 +7071,7 @@
         </p:nvSpPr>
         <p:spPr>
           <a:xfrm>
-            <a:off x="7720279" y="4032504"/>
+            <a:off x="7784287" y="4032504"/>
             <a:ext cx="36576" cy="2039112"/>
           </a:xfrm>
           <a:prstGeom prst="rect">
@@ -7049,7 +7091,7 @@
         </p:nvSpPr>
         <p:spPr>
           <a:xfrm>
-            <a:off x="7866583" y="4069080"/>
+            <a:off x="7930591" y="4069080"/>
             <a:ext cx="3584448" cy="201168"/>
           </a:xfrm>
           <a:prstGeom prst="rect">
@@ -7088,7 +7130,7 @@
         </p:nvSpPr>
         <p:spPr>
           <a:xfrm>
-            <a:off x="7866583" y="4270248"/>
+            <a:off x="7930591" y="4270248"/>
             <a:ext cx="3584448" cy="1819656"/>
           </a:xfrm>
           <a:prstGeom prst="rect">
@@ -7179,7 +7221,7 @@
         </p:nvSpPr>
         <p:spPr>
           <a:xfrm>
-            <a:off x="502920" y="6382512"/>
+            <a:off x="566928" y="6382512"/>
             <a:ext cx="7315200" cy="219456"/>
           </a:xfrm>
           <a:prstGeom prst="rect">
@@ -7218,7 +7260,7 @@
         </p:nvSpPr>
         <p:spPr>
           <a:xfrm>
-            <a:off x="10774375" y="6382512"/>
+            <a:off x="10710367" y="6382512"/>
             <a:ext cx="914400" cy="219456"/>
           </a:xfrm>
           <a:prstGeom prst="rect">
@@ -7289,7 +7331,7 @@
         </p:nvSpPr>
         <p:spPr>
           <a:xfrm>
-            <a:off x="502920" y="457200"/>
+            <a:off x="566928" y="457200"/>
             <a:ext cx="384048" cy="384048"/>
           </a:xfrm>
           <a:prstGeom prst="ellipse">
@@ -7309,7 +7351,7 @@
         </p:nvSpPr>
         <p:spPr>
           <a:xfrm>
-            <a:off x="502920" y="457200"/>
+            <a:off x="566928" y="457200"/>
             <a:ext cx="384048" cy="384048"/>
           </a:xfrm>
           <a:prstGeom prst="rect">
@@ -7348,7 +7390,7 @@
         </p:nvSpPr>
         <p:spPr>
           <a:xfrm>
-            <a:off x="1069848" y="457200"/>
+            <a:off x="1133856" y="457200"/>
             <a:ext cx="10490911" cy="182880"/>
           </a:xfrm>
           <a:prstGeom prst="rect">
@@ -7387,7 +7429,7 @@
         </p:nvSpPr>
         <p:spPr>
           <a:xfrm>
-            <a:off x="1069848" y="640080"/>
+            <a:off x="1133856" y="640080"/>
             <a:ext cx="10490911" cy="365760"/>
           </a:xfrm>
           <a:prstGeom prst="rect">
@@ -7397,7 +7439,9 @@
           <a:ln/>
         </p:spPr>
         <p:txBody>
-          <a:bodyPr wrap="square" lIns="0" tIns="0" rIns="0" bIns="0" rtlCol="0" anchor="ctr"/>
+          <a:bodyPr wrap="square" lIns="0" tIns="0" rIns="0" bIns="0" rtlCol="0" anchor="ctr">
+            <a:normAutofit/>
+          </a:bodyPr>
           <a:lstStyle/>
           <a:p>
             <a:pPr indent="0" marL="0">
@@ -7426,7 +7470,7 @@
         </p:nvSpPr>
         <p:spPr>
           <a:xfrm>
-            <a:off x="502920" y="1371600"/>
+            <a:off x="566928" y="1371600"/>
             <a:ext cx="6858000" cy="237744"/>
           </a:xfrm>
           <a:prstGeom prst="rect">
@@ -7465,7 +7509,7 @@
         </p:nvSpPr>
         <p:spPr>
           <a:xfrm>
-            <a:off x="502920" y="1645920"/>
+            <a:off x="566928" y="1645920"/>
             <a:ext cx="1920240" cy="402336"/>
           </a:xfrm>
           <a:prstGeom prst="rect">
@@ -7475,7 +7519,9 @@
           <a:ln/>
         </p:spPr>
         <p:txBody>
-          <a:bodyPr wrap="square" lIns="0" tIns="0" rIns="0" bIns="0" rtlCol="0" anchor="ctr"/>
+          <a:bodyPr wrap="square" lIns="0" tIns="0" rIns="0" bIns="0" rtlCol="0" anchor="ctr">
+            <a:normAutofit/>
+          </a:bodyPr>
           <a:lstStyle/>
           <a:p>
             <a:pPr indent="0" marL="0">
@@ -7507,7 +7553,7 @@
         </p:nvSpPr>
         <p:spPr>
           <a:xfrm>
-            <a:off x="2423160" y="1645920"/>
+            <a:off x="2487168" y="1645920"/>
             <a:ext cx="4937760" cy="402336"/>
           </a:xfrm>
           <a:prstGeom prst="rect">
@@ -7517,7 +7563,9 @@
           <a:ln/>
         </p:spPr>
         <p:txBody>
-          <a:bodyPr wrap="square" lIns="0" tIns="0" rIns="0" bIns="0" rtlCol="0" anchor="ctr"/>
+          <a:bodyPr wrap="square" lIns="0" tIns="0" rIns="0" bIns="0" rtlCol="0" anchor="ctr">
+            <a:normAutofit/>
+          </a:bodyPr>
           <a:lstStyle/>
           <a:p>
             <a:pPr indent="0" marL="0">
@@ -7549,7 +7597,7 @@
         </p:nvSpPr>
         <p:spPr>
           <a:xfrm>
-            <a:off x="502920" y="2048256"/>
+            <a:off x="566928" y="2048256"/>
             <a:ext cx="6858000" cy="0"/>
           </a:xfrm>
           <a:prstGeom prst="line">
@@ -7572,7 +7620,7 @@
         </p:nvSpPr>
         <p:spPr>
           <a:xfrm>
-            <a:off x="502920" y="2048256"/>
+            <a:off x="566928" y="2048256"/>
             <a:ext cx="1920240" cy="402336"/>
           </a:xfrm>
           <a:prstGeom prst="rect">
@@ -7582,7 +7630,9 @@
           <a:ln/>
         </p:spPr>
         <p:txBody>
-          <a:bodyPr wrap="square" lIns="0" tIns="0" rIns="0" bIns="0" rtlCol="0" anchor="ctr"/>
+          <a:bodyPr wrap="square" lIns="0" tIns="0" rIns="0" bIns="0" rtlCol="0" anchor="ctr">
+            <a:normAutofit/>
+          </a:bodyPr>
           <a:lstStyle/>
           <a:p>
             <a:pPr indent="0" marL="0">
@@ -7614,7 +7664,7 @@
         </p:nvSpPr>
         <p:spPr>
           <a:xfrm>
-            <a:off x="2423160" y="2048256"/>
+            <a:off x="2487168" y="2048256"/>
             <a:ext cx="4937760" cy="402336"/>
           </a:xfrm>
           <a:prstGeom prst="rect">
@@ -7624,7 +7674,9 @@
           <a:ln/>
         </p:spPr>
         <p:txBody>
-          <a:bodyPr wrap="square" lIns="0" tIns="0" rIns="0" bIns="0" rtlCol="0" anchor="ctr"/>
+          <a:bodyPr wrap="square" lIns="0" tIns="0" rIns="0" bIns="0" rtlCol="0" anchor="ctr">
+            <a:normAutofit/>
+          </a:bodyPr>
           <a:lstStyle/>
           <a:p>
             <a:pPr indent="0" marL="0">
@@ -7656,7 +7708,7 @@
         </p:nvSpPr>
         <p:spPr>
           <a:xfrm>
-            <a:off x="7540600" y="1371600"/>
+            <a:off x="7604608" y="1371600"/>
             <a:ext cx="0" cy="4754880"/>
           </a:xfrm>
           <a:prstGeom prst="line">
@@ -7679,7 +7731,7 @@
         </p:nvSpPr>
         <p:spPr>
           <a:xfrm>
-            <a:off x="7720279" y="1645920"/>
+            <a:off x="7784287" y="1645920"/>
             <a:ext cx="3840480" cy="1645920"/>
           </a:xfrm>
           <a:prstGeom prst="roundRect">
@@ -7701,7 +7753,7 @@
         </p:nvSpPr>
         <p:spPr>
           <a:xfrm>
-            <a:off x="7720279" y="1700784"/>
+            <a:off x="7784287" y="1700784"/>
             <a:ext cx="36576" cy="1536192"/>
           </a:xfrm>
           <a:prstGeom prst="rect">
@@ -7721,7 +7773,7 @@
         </p:nvSpPr>
         <p:spPr>
           <a:xfrm>
-            <a:off x="7866583" y="1737360"/>
+            <a:off x="7930591" y="1737360"/>
             <a:ext cx="3584448" cy="201168"/>
           </a:xfrm>
           <a:prstGeom prst="rect">
@@ -7749,7 +7801,7 @@
         </p:nvSpPr>
         <p:spPr>
           <a:xfrm>
-            <a:off x="7866583" y="1938528"/>
+            <a:off x="7930591" y="1938528"/>
             <a:ext cx="3584448" cy="1316736"/>
           </a:xfrm>
           <a:prstGeom prst="rect">
@@ -7791,7 +7843,7 @@
         </p:nvSpPr>
         <p:spPr>
           <a:xfrm>
-            <a:off x="502920" y="6382512"/>
+            <a:off x="566928" y="6382512"/>
             <a:ext cx="7315200" cy="219456"/>
           </a:xfrm>
           <a:prstGeom prst="rect">
@@ -7830,7 +7882,7 @@
         </p:nvSpPr>
         <p:spPr>
           <a:xfrm>
-            <a:off x="10774375" y="6382512"/>
+            <a:off x="10710367" y="6382512"/>
             <a:ext cx="914400" cy="219456"/>
           </a:xfrm>
           <a:prstGeom prst="rect">
@@ -7901,7 +7953,7 @@
         </p:nvSpPr>
         <p:spPr>
           <a:xfrm>
-            <a:off x="502920" y="457200"/>
+            <a:off x="566928" y="457200"/>
             <a:ext cx="384048" cy="384048"/>
           </a:xfrm>
           <a:prstGeom prst="ellipse">
@@ -7921,7 +7973,7 @@
         </p:nvSpPr>
         <p:spPr>
           <a:xfrm>
-            <a:off x="502920" y="457200"/>
+            <a:off x="566928" y="457200"/>
             <a:ext cx="384048" cy="384048"/>
           </a:xfrm>
           <a:prstGeom prst="rect">
@@ -7960,7 +8012,7 @@
         </p:nvSpPr>
         <p:spPr>
           <a:xfrm>
-            <a:off x="1069848" y="457200"/>
+            <a:off x="1133856" y="457200"/>
             <a:ext cx="10490911" cy="182880"/>
           </a:xfrm>
           <a:prstGeom prst="rect">
@@ -7999,7 +8051,7 @@
         </p:nvSpPr>
         <p:spPr>
           <a:xfrm>
-            <a:off x="1069848" y="640080"/>
+            <a:off x="1133856" y="640080"/>
             <a:ext cx="10490911" cy="365760"/>
           </a:xfrm>
           <a:prstGeom prst="rect">
@@ -8009,7 +8061,9 @@
           <a:ln/>
         </p:spPr>
         <p:txBody>
-          <a:bodyPr wrap="square" lIns="0" tIns="0" rIns="0" bIns="0" rtlCol="0" anchor="ctr"/>
+          <a:bodyPr wrap="square" lIns="0" tIns="0" rIns="0" bIns="0" rtlCol="0" anchor="ctr">
+            <a:normAutofit/>
+          </a:bodyPr>
           <a:lstStyle/>
           <a:p>
             <a:pPr indent="0" marL="0">
@@ -8038,7 +8092,7 @@
         </p:nvSpPr>
         <p:spPr>
           <a:xfrm>
-            <a:off x="502920" y="1417320"/>
+            <a:off x="566928" y="1417320"/>
             <a:ext cx="5391760" cy="4389120"/>
           </a:xfrm>
           <a:prstGeom prst="roundRect">
@@ -8065,7 +8119,7 @@
         </p:nvSpPr>
         <p:spPr>
           <a:xfrm>
-            <a:off x="731520" y="1618488"/>
+            <a:off x="795528" y="1618488"/>
             <a:ext cx="4934560" cy="320040"/>
           </a:xfrm>
           <a:prstGeom prst="rect">
@@ -8104,7 +8158,7 @@
         </p:nvSpPr>
         <p:spPr>
           <a:xfrm>
-            <a:off x="731520" y="2011680"/>
+            <a:off x="795528" y="2011680"/>
             <a:ext cx="2269897" cy="475488"/>
           </a:xfrm>
           <a:prstGeom prst="rect">
@@ -8114,7 +8168,9 @@
           <a:ln/>
         </p:spPr>
         <p:txBody>
-          <a:bodyPr wrap="square" lIns="0" tIns="0" rIns="0" bIns="0" rtlCol="0" anchor="ctr"/>
+          <a:bodyPr wrap="square" lIns="0" tIns="0" rIns="0" bIns="0" rtlCol="0" anchor="ctr">
+            <a:normAutofit/>
+          </a:bodyPr>
           <a:lstStyle/>
           <a:p>
             <a:pPr indent="0" marL="0">
@@ -8146,7 +8202,7 @@
         </p:nvSpPr>
         <p:spPr>
           <a:xfrm>
-            <a:off x="3001417" y="2011680"/>
+            <a:off x="3065425" y="2011680"/>
             <a:ext cx="2664662" cy="475488"/>
           </a:xfrm>
           <a:prstGeom prst="rect">
@@ -8156,7 +8212,9 @@
           <a:ln/>
         </p:spPr>
         <p:txBody>
-          <a:bodyPr wrap="square" lIns="0" tIns="0" rIns="0" bIns="0" rtlCol="0" anchor="ctr"/>
+          <a:bodyPr wrap="square" lIns="0" tIns="0" rIns="0" bIns="0" rtlCol="0" anchor="ctr">
+            <a:normAutofit/>
+          </a:bodyPr>
           <a:lstStyle/>
           <a:p>
             <a:pPr indent="0" marL="0">
@@ -8188,7 +8246,7 @@
         </p:nvSpPr>
         <p:spPr>
           <a:xfrm>
-            <a:off x="731520" y="2487168"/>
+            <a:off x="795528" y="2487168"/>
             <a:ext cx="4934560" cy="0"/>
           </a:xfrm>
           <a:prstGeom prst="line">
@@ -8211,7 +8269,7 @@
         </p:nvSpPr>
         <p:spPr>
           <a:xfrm>
-            <a:off x="731520" y="2487168"/>
+            <a:off x="795528" y="2487168"/>
             <a:ext cx="2269897" cy="475488"/>
           </a:xfrm>
           <a:prstGeom prst="rect">
@@ -8221,7 +8279,9 @@
           <a:ln/>
         </p:spPr>
         <p:txBody>
-          <a:bodyPr wrap="square" lIns="0" tIns="0" rIns="0" bIns="0" rtlCol="0" anchor="ctr"/>
+          <a:bodyPr wrap="square" lIns="0" tIns="0" rIns="0" bIns="0" rtlCol="0" anchor="ctr">
+            <a:normAutofit/>
+          </a:bodyPr>
           <a:lstStyle/>
           <a:p>
             <a:pPr indent="0" marL="0">
@@ -8253,7 +8313,7 @@
         </p:nvSpPr>
         <p:spPr>
           <a:xfrm>
-            <a:off x="3001417" y="2487168"/>
+            <a:off x="3065425" y="2487168"/>
             <a:ext cx="2664662" cy="475488"/>
           </a:xfrm>
           <a:prstGeom prst="rect">
@@ -8263,7 +8323,9 @@
           <a:ln/>
         </p:spPr>
         <p:txBody>
-          <a:bodyPr wrap="square" lIns="0" tIns="0" rIns="0" bIns="0" rtlCol="0" anchor="ctr"/>
+          <a:bodyPr wrap="square" lIns="0" tIns="0" rIns="0" bIns="0" rtlCol="0" anchor="ctr">
+            <a:normAutofit/>
+          </a:bodyPr>
           <a:lstStyle/>
           <a:p>
             <a:pPr indent="0" marL="0">
@@ -8295,7 +8357,7 @@
         </p:nvSpPr>
         <p:spPr>
           <a:xfrm>
-            <a:off x="731520" y="2962656"/>
+            <a:off x="795528" y="2962656"/>
             <a:ext cx="4934560" cy="0"/>
           </a:xfrm>
           <a:prstGeom prst="line">
@@ -8318,7 +8380,7 @@
         </p:nvSpPr>
         <p:spPr>
           <a:xfrm>
-            <a:off x="731520" y="2962656"/>
+            <a:off x="795528" y="2962656"/>
             <a:ext cx="2269897" cy="475488"/>
           </a:xfrm>
           <a:prstGeom prst="rect">
@@ -8328,7 +8390,9 @@
           <a:ln/>
         </p:spPr>
         <p:txBody>
-          <a:bodyPr wrap="square" lIns="0" tIns="0" rIns="0" bIns="0" rtlCol="0" anchor="ctr"/>
+          <a:bodyPr wrap="square" lIns="0" tIns="0" rIns="0" bIns="0" rtlCol="0" anchor="ctr">
+            <a:normAutofit/>
+          </a:bodyPr>
           <a:lstStyle/>
           <a:p>
             <a:pPr indent="0" marL="0">
@@ -8360,7 +8424,7 @@
         </p:nvSpPr>
         <p:spPr>
           <a:xfrm>
-            <a:off x="3001417" y="2962656"/>
+            <a:off x="3065425" y="2962656"/>
             <a:ext cx="2664662" cy="475488"/>
           </a:xfrm>
           <a:prstGeom prst="rect">
@@ -8370,7 +8434,9 @@
           <a:ln/>
         </p:spPr>
         <p:txBody>
-          <a:bodyPr wrap="square" lIns="0" tIns="0" rIns="0" bIns="0" rtlCol="0" anchor="ctr"/>
+          <a:bodyPr wrap="square" lIns="0" tIns="0" rIns="0" bIns="0" rtlCol="0" anchor="ctr">
+            <a:normAutofit/>
+          </a:bodyPr>
           <a:lstStyle/>
           <a:p>
             <a:pPr indent="0" marL="0">
@@ -8402,7 +8468,7 @@
         </p:nvSpPr>
         <p:spPr>
           <a:xfrm>
-            <a:off x="731520" y="3438144"/>
+            <a:off x="795528" y="3438144"/>
             <a:ext cx="4934560" cy="0"/>
           </a:xfrm>
           <a:prstGeom prst="line">
@@ -8425,7 +8491,7 @@
         </p:nvSpPr>
         <p:spPr>
           <a:xfrm>
-            <a:off x="731520" y="3438144"/>
+            <a:off x="795528" y="3438144"/>
             <a:ext cx="2269897" cy="475488"/>
           </a:xfrm>
           <a:prstGeom prst="rect">
@@ -8435,7 +8501,9 @@
           <a:ln/>
         </p:spPr>
         <p:txBody>
-          <a:bodyPr wrap="square" lIns="0" tIns="0" rIns="0" bIns="0" rtlCol="0" anchor="ctr"/>
+          <a:bodyPr wrap="square" lIns="0" tIns="0" rIns="0" bIns="0" rtlCol="0" anchor="ctr">
+            <a:normAutofit/>
+          </a:bodyPr>
           <a:lstStyle/>
           <a:p>
             <a:pPr indent="0" marL="0">
@@ -8467,7 +8535,7 @@
         </p:nvSpPr>
         <p:spPr>
           <a:xfrm>
-            <a:off x="3001417" y="3438144"/>
+            <a:off x="3065425" y="3438144"/>
             <a:ext cx="2664662" cy="475488"/>
           </a:xfrm>
           <a:prstGeom prst="rect">
@@ -8477,7 +8545,9 @@
           <a:ln/>
         </p:spPr>
         <p:txBody>
-          <a:bodyPr wrap="square" lIns="0" tIns="0" rIns="0" bIns="0" rtlCol="0" anchor="ctr"/>
+          <a:bodyPr wrap="square" lIns="0" tIns="0" rIns="0" bIns="0" rtlCol="0" anchor="ctr">
+            <a:normAutofit/>
+          </a:bodyPr>
           <a:lstStyle/>
           <a:p>
             <a:pPr indent="0" marL="0">
@@ -8509,7 +8579,7 @@
         </p:nvSpPr>
         <p:spPr>
           <a:xfrm>
-            <a:off x="731520" y="3913632"/>
+            <a:off x="795528" y="3913632"/>
             <a:ext cx="4934560" cy="0"/>
           </a:xfrm>
           <a:prstGeom prst="line">
@@ -8532,7 +8602,7 @@
         </p:nvSpPr>
         <p:spPr>
           <a:xfrm>
-            <a:off x="731520" y="3913632"/>
+            <a:off x="795528" y="3913632"/>
             <a:ext cx="2269897" cy="475488"/>
           </a:xfrm>
           <a:prstGeom prst="rect">
@@ -8542,7 +8612,9 @@
           <a:ln/>
         </p:spPr>
         <p:txBody>
-          <a:bodyPr wrap="square" lIns="0" tIns="0" rIns="0" bIns="0" rtlCol="0" anchor="ctr"/>
+          <a:bodyPr wrap="square" lIns="0" tIns="0" rIns="0" bIns="0" rtlCol="0" anchor="ctr">
+            <a:normAutofit/>
+          </a:bodyPr>
           <a:lstStyle/>
           <a:p>
             <a:pPr indent="0" marL="0">
@@ -8574,7 +8646,7 @@
         </p:nvSpPr>
         <p:spPr>
           <a:xfrm>
-            <a:off x="3001417" y="3913632"/>
+            <a:off x="3065425" y="3913632"/>
             <a:ext cx="2664662" cy="475488"/>
           </a:xfrm>
           <a:prstGeom prst="rect">
@@ -8584,7 +8656,9 @@
           <a:ln/>
         </p:spPr>
         <p:txBody>
-          <a:bodyPr wrap="square" lIns="0" tIns="0" rIns="0" bIns="0" rtlCol="0" anchor="ctr"/>
+          <a:bodyPr wrap="square" lIns="0" tIns="0" rIns="0" bIns="0" rtlCol="0" anchor="ctr">
+            <a:normAutofit/>
+          </a:bodyPr>
           <a:lstStyle/>
           <a:p>
             <a:pPr indent="0" marL="0">
@@ -8616,7 +8690,7 @@
         </p:nvSpPr>
         <p:spPr>
           <a:xfrm>
-            <a:off x="731520" y="4389120"/>
+            <a:off x="795528" y="4389120"/>
             <a:ext cx="4934560" cy="0"/>
           </a:xfrm>
           <a:prstGeom prst="line">
@@ -8639,7 +8713,7 @@
         </p:nvSpPr>
         <p:spPr>
           <a:xfrm>
-            <a:off x="731520" y="4389120"/>
+            <a:off x="795528" y="4389120"/>
             <a:ext cx="2269897" cy="475488"/>
           </a:xfrm>
           <a:prstGeom prst="rect">
@@ -8649,7 +8723,9 @@
           <a:ln/>
         </p:spPr>
         <p:txBody>
-          <a:bodyPr wrap="square" lIns="0" tIns="0" rIns="0" bIns="0" rtlCol="0" anchor="ctr"/>
+          <a:bodyPr wrap="square" lIns="0" tIns="0" rIns="0" bIns="0" rtlCol="0" anchor="ctr">
+            <a:normAutofit/>
+          </a:bodyPr>
           <a:lstStyle/>
           <a:p>
             <a:pPr indent="0" marL="0">
@@ -8681,7 +8757,7 @@
         </p:nvSpPr>
         <p:spPr>
           <a:xfrm>
-            <a:off x="3001417" y="4389120"/>
+            <a:off x="3065425" y="4389120"/>
             <a:ext cx="2664662" cy="475488"/>
           </a:xfrm>
           <a:prstGeom prst="rect">
@@ -8691,7 +8767,9 @@
           <a:ln/>
         </p:spPr>
         <p:txBody>
-          <a:bodyPr wrap="square" lIns="0" tIns="0" rIns="0" bIns="0" rtlCol="0" anchor="ctr"/>
+          <a:bodyPr wrap="square" lIns="0" tIns="0" rIns="0" bIns="0" rtlCol="0" anchor="ctr">
+            <a:normAutofit/>
+          </a:bodyPr>
           <a:lstStyle/>
           <a:p>
             <a:pPr indent="0" marL="0">
@@ -8723,7 +8801,7 @@
         </p:nvSpPr>
         <p:spPr>
           <a:xfrm>
-            <a:off x="731520" y="4864608"/>
+            <a:off x="795528" y="4864608"/>
             <a:ext cx="4934560" cy="0"/>
           </a:xfrm>
           <a:prstGeom prst="line">
@@ -8746,7 +8824,7 @@
         </p:nvSpPr>
         <p:spPr>
           <a:xfrm>
-            <a:off x="731520" y="4864608"/>
+            <a:off x="795528" y="4864608"/>
             <a:ext cx="2269897" cy="475488"/>
           </a:xfrm>
           <a:prstGeom prst="rect">
@@ -8756,7 +8834,9 @@
           <a:ln/>
         </p:spPr>
         <p:txBody>
-          <a:bodyPr wrap="square" lIns="0" tIns="0" rIns="0" bIns="0" rtlCol="0" anchor="ctr"/>
+          <a:bodyPr wrap="square" lIns="0" tIns="0" rIns="0" bIns="0" rtlCol="0" anchor="ctr">
+            <a:normAutofit/>
+          </a:bodyPr>
           <a:lstStyle/>
           <a:p>
             <a:pPr indent="0" marL="0">
@@ -8788,7 +8868,7 @@
         </p:nvSpPr>
         <p:spPr>
           <a:xfrm>
-            <a:off x="3001417" y="4864608"/>
+            <a:off x="3065425" y="4864608"/>
             <a:ext cx="2664662" cy="475488"/>
           </a:xfrm>
           <a:prstGeom prst="rect">
@@ -8798,7 +8878,9 @@
           <a:ln/>
         </p:spPr>
         <p:txBody>
-          <a:bodyPr wrap="square" lIns="0" tIns="0" rIns="0" bIns="0" rtlCol="0" anchor="ctr"/>
+          <a:bodyPr wrap="square" lIns="0" tIns="0" rIns="0" bIns="0" rtlCol="0" anchor="ctr">
+            <a:normAutofit/>
+          </a:bodyPr>
           <a:lstStyle/>
           <a:p>
             <a:pPr indent="0" marL="0">
@@ -8830,7 +8912,7 @@
         </p:nvSpPr>
         <p:spPr>
           <a:xfrm>
-            <a:off x="6169000" y="1417320"/>
+            <a:off x="6233008" y="1417320"/>
             <a:ext cx="5391760" cy="4389120"/>
           </a:xfrm>
           <a:prstGeom prst="roundRect">
@@ -8857,7 +8939,7 @@
         </p:nvSpPr>
         <p:spPr>
           <a:xfrm>
-            <a:off x="6397600" y="1618488"/>
+            <a:off x="6461608" y="1618488"/>
             <a:ext cx="4934560" cy="320040"/>
           </a:xfrm>
           <a:prstGeom prst="rect">
@@ -8903,7 +8985,7 @@
           </p:nvPr>
         </p:nvGraphicFramePr>
         <p:xfrm>
-          <a:off x="6397600" y="2057400"/>
+          <a:off x="6461608" y="2057400"/>
           <a:ext cx="4934560" cy="914400"/>
         </p:xfrm>
         <a:graphic>
@@ -10410,7 +10492,7 @@
         </p:nvSpPr>
         <p:spPr>
           <a:xfrm>
-            <a:off x="6397600" y="4069080"/>
+            <a:off x="6461608" y="4069080"/>
             <a:ext cx="4934560" cy="1463040"/>
           </a:xfrm>
           <a:prstGeom prst="roundRect">
@@ -10432,7 +10514,7 @@
         </p:nvSpPr>
         <p:spPr>
           <a:xfrm>
-            <a:off x="6397600" y="4123944"/>
+            <a:off x="6461608" y="4123944"/>
             <a:ext cx="36576" cy="1353312"/>
           </a:xfrm>
           <a:prstGeom prst="rect">
@@ -10452,7 +10534,7 @@
         </p:nvSpPr>
         <p:spPr>
           <a:xfrm>
-            <a:off x="6543904" y="4160520"/>
+            <a:off x="6607912" y="4160520"/>
             <a:ext cx="4678528" cy="201168"/>
           </a:xfrm>
           <a:prstGeom prst="rect">
@@ -10491,7 +10573,7 @@
         </p:nvSpPr>
         <p:spPr>
           <a:xfrm>
-            <a:off x="6543904" y="4361688"/>
+            <a:off x="6607912" y="4361688"/>
             <a:ext cx="4678528" cy="1133856"/>
           </a:xfrm>
           <a:prstGeom prst="rect">
@@ -10533,7 +10615,7 @@
         </p:nvSpPr>
         <p:spPr>
           <a:xfrm>
-            <a:off x="502920" y="6382512"/>
+            <a:off x="566928" y="6382512"/>
             <a:ext cx="7315200" cy="219456"/>
           </a:xfrm>
           <a:prstGeom prst="rect">
@@ -10572,7 +10654,7 @@
         </p:nvSpPr>
         <p:spPr>
           <a:xfrm>
-            <a:off x="10774375" y="6382512"/>
+            <a:off x="10710367" y="6382512"/>
             <a:ext cx="914400" cy="219456"/>
           </a:xfrm>
           <a:prstGeom prst="rect">
@@ -10643,7 +10725,7 @@
         </p:nvSpPr>
         <p:spPr>
           <a:xfrm>
-            <a:off x="502920" y="457200"/>
+            <a:off x="566928" y="457200"/>
             <a:ext cx="384048" cy="384048"/>
           </a:xfrm>
           <a:prstGeom prst="ellipse">
@@ -10663,7 +10745,7 @@
         </p:nvSpPr>
         <p:spPr>
           <a:xfrm>
-            <a:off x="502920" y="457200"/>
+            <a:off x="566928" y="457200"/>
             <a:ext cx="384048" cy="384048"/>
           </a:xfrm>
           <a:prstGeom prst="rect">
@@ -10702,7 +10784,7 @@
         </p:nvSpPr>
         <p:spPr>
           <a:xfrm>
-            <a:off x="1069848" y="457200"/>
+            <a:off x="1133856" y="457200"/>
             <a:ext cx="10490911" cy="182880"/>
           </a:xfrm>
           <a:prstGeom prst="rect">
@@ -10741,7 +10823,7 @@
         </p:nvSpPr>
         <p:spPr>
           <a:xfrm>
-            <a:off x="1069848" y="640080"/>
+            <a:off x="1133856" y="640080"/>
             <a:ext cx="10490911" cy="365760"/>
           </a:xfrm>
           <a:prstGeom prst="rect">
@@ -10751,7 +10833,9 @@
           <a:ln/>
         </p:spPr>
         <p:txBody>
-          <a:bodyPr wrap="square" lIns="0" tIns="0" rIns="0" bIns="0" rtlCol="0" anchor="ctr"/>
+          <a:bodyPr wrap="square" lIns="0" tIns="0" rIns="0" bIns="0" rtlCol="0" anchor="ctr">
+            <a:normAutofit/>
+          </a:bodyPr>
           <a:lstStyle/>
           <a:p>
             <a:pPr indent="0" marL="0">
@@ -10780,7 +10864,7 @@
         </p:nvSpPr>
         <p:spPr>
           <a:xfrm>
-            <a:off x="502920" y="4937760"/>
+            <a:off x="566928" y="4937760"/>
             <a:ext cx="11057839" cy="804672"/>
           </a:xfrm>
           <a:prstGeom prst="roundRect">
@@ -10807,7 +10891,7 @@
         </p:nvSpPr>
         <p:spPr>
           <a:xfrm>
-            <a:off x="685800" y="5047488"/>
+            <a:off x="749808" y="5047488"/>
             <a:ext cx="1691640" cy="256032"/>
           </a:xfrm>
           <a:prstGeom prst="rect">
@@ -10846,7 +10930,7 @@
         </p:nvSpPr>
         <p:spPr>
           <a:xfrm>
-            <a:off x="2423160" y="5010912"/>
+            <a:off x="2487168" y="5010912"/>
             <a:ext cx="8954719" cy="658368"/>
           </a:xfrm>
           <a:prstGeom prst="rect">
@@ -10888,7 +10972,7 @@
         </p:nvSpPr>
         <p:spPr>
           <a:xfrm>
-            <a:off x="502920" y="6382512"/>
+            <a:off x="566928" y="6382512"/>
             <a:ext cx="7315200" cy="219456"/>
           </a:xfrm>
           <a:prstGeom prst="rect">
@@ -10927,7 +11011,7 @@
         </p:nvSpPr>
         <p:spPr>
           <a:xfrm>
-            <a:off x="10774375" y="6382512"/>
+            <a:off x="10710367" y="6382512"/>
             <a:ext cx="914400" cy="219456"/>
           </a:xfrm>
           <a:prstGeom prst="rect">
@@ -10998,7 +11082,7 @@
         </p:nvSpPr>
         <p:spPr>
           <a:xfrm>
-            <a:off x="502920" y="457200"/>
+            <a:off x="566928" y="457200"/>
             <a:ext cx="384048" cy="384048"/>
           </a:xfrm>
           <a:prstGeom prst="ellipse">
@@ -11018,7 +11102,7 @@
         </p:nvSpPr>
         <p:spPr>
           <a:xfrm>
-            <a:off x="502920" y="457200"/>
+            <a:off x="566928" y="457200"/>
             <a:ext cx="384048" cy="384048"/>
           </a:xfrm>
           <a:prstGeom prst="rect">
@@ -11057,7 +11141,7 @@
         </p:nvSpPr>
         <p:spPr>
           <a:xfrm>
-            <a:off x="1069848" y="457200"/>
+            <a:off x="1133856" y="457200"/>
             <a:ext cx="10490911" cy="182880"/>
           </a:xfrm>
           <a:prstGeom prst="rect">
@@ -11096,7 +11180,7 @@
         </p:nvSpPr>
         <p:spPr>
           <a:xfrm>
-            <a:off x="1069848" y="640080"/>
+            <a:off x="1133856" y="640080"/>
             <a:ext cx="10490911" cy="365760"/>
           </a:xfrm>
           <a:prstGeom prst="rect">
@@ -11106,7 +11190,9 @@
           <a:ln/>
         </p:spPr>
         <p:txBody>
-          <a:bodyPr wrap="square" lIns="0" tIns="0" rIns="0" bIns="0" rtlCol="0" anchor="ctr"/>
+          <a:bodyPr wrap="square" lIns="0" tIns="0" rIns="0" bIns="0" rtlCol="0" anchor="ctr">
+            <a:normAutofit/>
+          </a:bodyPr>
           <a:lstStyle/>
           <a:p>
             <a:pPr indent="0" marL="0">
@@ -11135,7 +11221,7 @@
         </p:nvSpPr>
         <p:spPr>
           <a:xfrm>
-            <a:off x="502920" y="1417320"/>
+            <a:off x="566928" y="1417320"/>
             <a:ext cx="11057839" cy="3657600"/>
           </a:xfrm>
           <a:prstGeom prst="roundRect">
@@ -11162,7 +11248,7 @@
         </p:nvSpPr>
         <p:spPr>
           <a:xfrm>
-            <a:off x="502920" y="1417320"/>
+            <a:off x="566928" y="1417320"/>
             <a:ext cx="11057839" cy="45720"/>
           </a:xfrm>
           <a:prstGeom prst="rect">
@@ -11182,7 +11268,7 @@
         </p:nvSpPr>
         <p:spPr>
           <a:xfrm>
-            <a:off x="731520" y="1618488"/>
+            <a:off x="795528" y="1618488"/>
             <a:ext cx="10600639" cy="292608"/>
           </a:xfrm>
           <a:prstGeom prst="rect">
@@ -11221,7 +11307,7 @@
         </p:nvSpPr>
         <p:spPr>
           <a:xfrm>
-            <a:off x="731520" y="1947672"/>
+            <a:off x="795528" y="1947672"/>
             <a:ext cx="10600639" cy="365760"/>
           </a:xfrm>
           <a:prstGeom prst="rect">
@@ -11262,7 +11348,7 @@
         </p:nvSpPr>
         <p:spPr>
           <a:xfrm>
-            <a:off x="731520" y="2377440"/>
+            <a:off x="795528" y="2377440"/>
             <a:ext cx="10600639" cy="2606040"/>
           </a:xfrm>
           <a:prstGeom prst="rect">
@@ -11307,7 +11393,7 @@
         </p:nvSpPr>
         <p:spPr>
           <a:xfrm>
-            <a:off x="502920" y="5193792"/>
+            <a:off x="566928" y="5193792"/>
             <a:ext cx="11057839" cy="621792"/>
           </a:xfrm>
           <a:prstGeom prst="roundRect">
@@ -11334,7 +11420,7 @@
         </p:nvSpPr>
         <p:spPr>
           <a:xfrm>
-            <a:off x="731520" y="5193792"/>
+            <a:off x="795528" y="5193792"/>
             <a:ext cx="10600639" cy="621792"/>
           </a:xfrm>
           <a:prstGeom prst="rect">
@@ -11373,7 +11459,7 @@
         </p:nvSpPr>
         <p:spPr>
           <a:xfrm>
-            <a:off x="502920" y="6382512"/>
+            <a:off x="566928" y="6382512"/>
             <a:ext cx="7315200" cy="219456"/>
           </a:xfrm>
           <a:prstGeom prst="rect">
@@ -11412,7 +11498,7 @@
         </p:nvSpPr>
         <p:spPr>
           <a:xfrm>
-            <a:off x="10774375" y="6382512"/>
+            <a:off x="10710367" y="6382512"/>
             <a:ext cx="914400" cy="219456"/>
           </a:xfrm>
           <a:prstGeom prst="rect">
@@ -11483,7 +11569,7 @@
         </p:nvSpPr>
         <p:spPr>
           <a:xfrm>
-            <a:off x="502920" y="457200"/>
+            <a:off x="566928" y="457200"/>
             <a:ext cx="384048" cy="384048"/>
           </a:xfrm>
           <a:prstGeom prst="ellipse">
@@ -11503,7 +11589,7 @@
         </p:nvSpPr>
         <p:spPr>
           <a:xfrm>
-            <a:off x="502920" y="457200"/>
+            <a:off x="566928" y="457200"/>
             <a:ext cx="384048" cy="384048"/>
           </a:xfrm>
           <a:prstGeom prst="rect">
@@ -11542,7 +11628,7 @@
         </p:nvSpPr>
         <p:spPr>
           <a:xfrm>
-            <a:off x="1069848" y="457200"/>
+            <a:off x="1133856" y="457200"/>
             <a:ext cx="10490911" cy="182880"/>
           </a:xfrm>
           <a:prstGeom prst="rect">
@@ -11581,7 +11667,7 @@
         </p:nvSpPr>
         <p:spPr>
           <a:xfrm>
-            <a:off x="1069848" y="640080"/>
+            <a:off x="1133856" y="640080"/>
             <a:ext cx="10490911" cy="365760"/>
           </a:xfrm>
           <a:prstGeom prst="rect">
@@ -11591,7 +11677,9 @@
           <a:ln/>
         </p:spPr>
         <p:txBody>
-          <a:bodyPr wrap="square" lIns="0" tIns="0" rIns="0" bIns="0" rtlCol="0" anchor="ctr"/>
+          <a:bodyPr wrap="square" lIns="0" tIns="0" rIns="0" bIns="0" rtlCol="0" anchor="ctr">
+            <a:normAutofit/>
+          </a:bodyPr>
           <a:lstStyle/>
           <a:p>
             <a:pPr indent="0" marL="0">
@@ -11620,7 +11708,7 @@
         </p:nvSpPr>
         <p:spPr>
           <a:xfrm>
-            <a:off x="502920" y="1371600"/>
+            <a:off x="566928" y="1371600"/>
             <a:ext cx="11057839" cy="237744"/>
           </a:xfrm>
           <a:prstGeom prst="rect">
@@ -11659,7 +11747,7 @@
         </p:nvSpPr>
         <p:spPr>
           <a:xfrm>
-            <a:off x="502920" y="1719072"/>
+            <a:off x="566928" y="1719072"/>
             <a:ext cx="5368900" cy="749808"/>
           </a:xfrm>
           <a:prstGeom prst="rect">
@@ -11684,7 +11772,7 @@
         </p:nvSpPr>
         <p:spPr>
           <a:xfrm>
-            <a:off x="640080" y="1947672"/>
+            <a:off x="704088" y="1947672"/>
             <a:ext cx="292608" cy="292608"/>
           </a:xfrm>
           <a:prstGeom prst="rect">
@@ -11704,7 +11792,7 @@
         </p:nvSpPr>
         <p:spPr>
           <a:xfrm>
-            <a:off x="640080" y="1947672"/>
+            <a:off x="704088" y="1947672"/>
             <a:ext cx="292608" cy="292608"/>
           </a:xfrm>
           <a:prstGeom prst="rect">
@@ -11743,7 +11831,7 @@
         </p:nvSpPr>
         <p:spPr>
           <a:xfrm>
-            <a:off x="1033272" y="1792224"/>
+            <a:off x="1097280" y="1792224"/>
             <a:ext cx="4710532" cy="603504"/>
           </a:xfrm>
           <a:prstGeom prst="rect">
@@ -11785,7 +11873,7 @@
         </p:nvSpPr>
         <p:spPr>
           <a:xfrm>
-            <a:off x="502920" y="2542032"/>
+            <a:off x="566928" y="2542032"/>
             <a:ext cx="5368900" cy="749808"/>
           </a:xfrm>
           <a:prstGeom prst="rect">
@@ -11810,7 +11898,7 @@
         </p:nvSpPr>
         <p:spPr>
           <a:xfrm>
-            <a:off x="640080" y="2770632"/>
+            <a:off x="704088" y="2770632"/>
             <a:ext cx="292608" cy="292608"/>
           </a:xfrm>
           <a:prstGeom prst="rect">
@@ -11830,7 +11918,7 @@
         </p:nvSpPr>
         <p:spPr>
           <a:xfrm>
-            <a:off x="640080" y="2770632"/>
+            <a:off x="704088" y="2770632"/>
             <a:ext cx="292608" cy="292608"/>
           </a:xfrm>
           <a:prstGeom prst="rect">
@@ -11869,7 +11957,7 @@
         </p:nvSpPr>
         <p:spPr>
           <a:xfrm>
-            <a:off x="1033272" y="2615184"/>
+            <a:off x="1097280" y="2615184"/>
             <a:ext cx="4710532" cy="603504"/>
           </a:xfrm>
           <a:prstGeom prst="rect">
@@ -11911,7 +11999,7 @@
         </p:nvSpPr>
         <p:spPr>
           <a:xfrm>
-            <a:off x="502920" y="3364992"/>
+            <a:off x="566928" y="3364992"/>
             <a:ext cx="5368900" cy="749808"/>
           </a:xfrm>
           <a:prstGeom prst="rect">
@@ -11936,7 +12024,7 @@
         </p:nvSpPr>
         <p:spPr>
           <a:xfrm>
-            <a:off x="640080" y="3593592"/>
+            <a:off x="704088" y="3593592"/>
             <a:ext cx="292608" cy="292608"/>
           </a:xfrm>
           <a:prstGeom prst="rect">
@@ -11956,7 +12044,7 @@
         </p:nvSpPr>
         <p:spPr>
           <a:xfrm>
-            <a:off x="640080" y="3593592"/>
+            <a:off x="704088" y="3593592"/>
             <a:ext cx="292608" cy="292608"/>
           </a:xfrm>
           <a:prstGeom prst="rect">
@@ -11995,7 +12083,7 @@
         </p:nvSpPr>
         <p:spPr>
           <a:xfrm>
-            <a:off x="1033272" y="3438144"/>
+            <a:off x="1097280" y="3438144"/>
             <a:ext cx="4710532" cy="603504"/>
           </a:xfrm>
           <a:prstGeom prst="rect">
@@ -12037,7 +12125,7 @@
         </p:nvSpPr>
         <p:spPr>
           <a:xfrm>
-            <a:off x="6191860" y="1719072"/>
+            <a:off x="6255868" y="1719072"/>
             <a:ext cx="5368900" cy="749808"/>
           </a:xfrm>
           <a:prstGeom prst="rect">
@@ -12062,7 +12150,7 @@
         </p:nvSpPr>
         <p:spPr>
           <a:xfrm>
-            <a:off x="6329020" y="1947672"/>
+            <a:off x="6393028" y="1947672"/>
             <a:ext cx="292608" cy="292608"/>
           </a:xfrm>
           <a:prstGeom prst="rect">
@@ -12082,7 +12170,7 @@
         </p:nvSpPr>
         <p:spPr>
           <a:xfrm>
-            <a:off x="6329020" y="1947672"/>
+            <a:off x="6393028" y="1947672"/>
             <a:ext cx="292608" cy="292608"/>
           </a:xfrm>
           <a:prstGeom prst="rect">
@@ -12121,7 +12209,7 @@
         </p:nvSpPr>
         <p:spPr>
           <a:xfrm>
-            <a:off x="6722212" y="1792224"/>
+            <a:off x="6786220" y="1792224"/>
             <a:ext cx="4710532" cy="603504"/>
           </a:xfrm>
           <a:prstGeom prst="rect">
@@ -12163,7 +12251,7 @@
         </p:nvSpPr>
         <p:spPr>
           <a:xfrm>
-            <a:off x="6191860" y="2542032"/>
+            <a:off x="6255868" y="2542032"/>
             <a:ext cx="5368900" cy="749808"/>
           </a:xfrm>
           <a:prstGeom prst="rect">
@@ -12188,7 +12276,7 @@
         </p:nvSpPr>
         <p:spPr>
           <a:xfrm>
-            <a:off x="6329020" y="2770632"/>
+            <a:off x="6393028" y="2770632"/>
             <a:ext cx="292608" cy="292608"/>
           </a:xfrm>
           <a:prstGeom prst="rect">
@@ -12208,7 +12296,7 @@
         </p:nvSpPr>
         <p:spPr>
           <a:xfrm>
-            <a:off x="6329020" y="2770632"/>
+            <a:off x="6393028" y="2770632"/>
             <a:ext cx="292608" cy="292608"/>
           </a:xfrm>
           <a:prstGeom prst="rect">
@@ -12247,7 +12335,7 @@
         </p:nvSpPr>
         <p:spPr>
           <a:xfrm>
-            <a:off x="6722212" y="2615184"/>
+            <a:off x="6786220" y="2615184"/>
             <a:ext cx="4710532" cy="603504"/>
           </a:xfrm>
           <a:prstGeom prst="rect">
@@ -12289,7 +12377,7 @@
         </p:nvSpPr>
         <p:spPr>
           <a:xfrm>
-            <a:off x="6191860" y="3364992"/>
+            <a:off x="6255868" y="3364992"/>
             <a:ext cx="5368900" cy="749808"/>
           </a:xfrm>
           <a:prstGeom prst="rect">
@@ -12314,7 +12402,7 @@
         </p:nvSpPr>
         <p:spPr>
           <a:xfrm>
-            <a:off x="6329020" y="3593592"/>
+            <a:off x="6393028" y="3593592"/>
             <a:ext cx="292608" cy="292608"/>
           </a:xfrm>
           <a:prstGeom prst="rect">
@@ -12334,7 +12422,7 @@
         </p:nvSpPr>
         <p:spPr>
           <a:xfrm>
-            <a:off x="6329020" y="3593592"/>
+            <a:off x="6393028" y="3593592"/>
             <a:ext cx="292608" cy="292608"/>
           </a:xfrm>
           <a:prstGeom prst="rect">
@@ -12373,7 +12461,7 @@
         </p:nvSpPr>
         <p:spPr>
           <a:xfrm>
-            <a:off x="6722212" y="3438144"/>
+            <a:off x="6786220" y="3438144"/>
             <a:ext cx="4710532" cy="603504"/>
           </a:xfrm>
           <a:prstGeom prst="rect">
@@ -12415,7 +12503,7 @@
         </p:nvSpPr>
         <p:spPr>
           <a:xfrm>
-            <a:off x="502920" y="5349240"/>
+            <a:off x="566928" y="5349240"/>
             <a:ext cx="11057839" cy="457200"/>
           </a:xfrm>
           <a:prstGeom prst="rect">
@@ -12435,7 +12523,7 @@
         </p:nvSpPr>
         <p:spPr>
           <a:xfrm>
-            <a:off x="685800" y="5422392"/>
+            <a:off x="749808" y="5422392"/>
             <a:ext cx="10692079" cy="310896"/>
           </a:xfrm>
           <a:prstGeom prst="rect">
@@ -12474,7 +12562,7 @@
         </p:nvSpPr>
         <p:spPr>
           <a:xfrm>
-            <a:off x="502920" y="6382512"/>
+            <a:off x="566928" y="6382512"/>
             <a:ext cx="7315200" cy="219456"/>
           </a:xfrm>
           <a:prstGeom prst="rect">
@@ -12513,7 +12601,7 @@
         </p:nvSpPr>
         <p:spPr>
           <a:xfrm>
-            <a:off x="10774375" y="6382512"/>
+            <a:off x="10710367" y="6382512"/>
             <a:ext cx="914400" cy="219456"/>
           </a:xfrm>
           <a:prstGeom prst="rect">

</xml_diff>